<commit_message>
Pitch deck: growing with the EV market, surplus towards ESB hydrogen (#76)
Slide 4 now says what the Dashboard shows: the battery fills, and once it is full its surplus goes
towards ESB's hydrogen plants (simulated, no agreement). Slide 12 becomes "We grow as the EV market
grows": three stages from backend/hydrogen.py on GridToEv 1.1.0's real +30-min predictions for
24-31 Jan (EVs 29% -> 59% -> 84%, hydrogen 48% -> 29% -> 10%), written reproducibly by
docs/demo/hydrogen_stages.py. Slide 13: 457 tests. Slide 14 closes on hydrogen. Script still 7:00;
evidence ledger, Q&A and README updated.

Co-Authored-By: Claude Opus 5.5 <noreply@anthropic.com>
Claude-Session: https://claude.ai/code/session_01RfTe9B7YLtwgkBSipdKd8Q
</commit_message>
<xml_diff>
--- a/docs/demo/SaveThePlanet-pitch.pptx
+++ b/docs/demo/SaveThePlanet-pitch.pptx
@@ -794,12 +794,12 @@
           <a:p>
             <a:r>
               <a:rPr lang="en-US" dirty="0"/>
-              <a:t>5:30–6:10 · Scale
-ON SCREEN: Slide 12. Read along the 100-sites column.
-SAY (79 words):
-We'd start with one Irish charging operator and one site, to prove the energy, the prices and the bookings in the real world. After that it's the same software on every new site, each one capped by its own chargers. At a hundred sites that's about half a million euro a year back to drivers, and around two thousand four hundred tonnes of CO₂. Other European grids have the same problem; each needs its own data and model training.
-CAPTION: One site, then a hundred: €480,000 a year to drivers and about 2,400 t CO₂ (illustrative).
-EVIDENCE: E16 in docs/demo/evidence-ledger.md</a:t>
+              <a:t>5:30–6:10 · Growing with EVs
+ON SCREEN: Slide 12. Read the green part of each bar from top to bottom, then point at the violet.
+SAY (75 words):
+And our business grows as the EV market grows. In this replayed week, today's EVs could use about thirty percent of the spare power we can reach. As more depots, workplaces and public chargers join, that rises to nearly sixty, then over eighty percent. What cars can't use fills the battery, and once it's full, the surplus goes towards ESB's hydrogen plants instead of being wasted. We'd start with one Irish site, then repeat it.
+CAPTION: As EVs grow they take 29%, then 59%, then 84% of the reachable surplus; once the battery is full, the rest goes towards hydrogen. Simulated, no ESB agreement.
+EVIDENCE: E16, E18, E19, E20 in docs/demo/evidence-ledger.md</a:t>
             </a:r>
             <a:endParaRPr lang="en-US" dirty="0"/>
           </a:p>
@@ -890,8 +890,8 @@
               <a:t>6:10–6:40 · Proof
 ON SCREEN: Slide 13.
 SAY (53 words):
-Under the hood, EirGrid's data feeds the GridToEv model, a site check and a settlement ledger that works in whole cents. Four hundred and twenty automated tests run on every change. The splits and profits you've just seen come straight from that code, and replaying the same day always gives the same answer.
-CAPTION: EirGrid data, GridToEv forecast, site check, settlement ledger, app. 420 tests on every change.
+Under the hood, EirGrid's data feeds the GridToEv model, a site check and a settlement ledger that works in whole cents. Four hundred and fifty-seven automated tests run on every change. The splits and profits you've just seen come straight from that code, and replaying the same day always gives the same answer.
+CAPTION: EirGrid data, GridToEv forecast, site check, settlement ledger, app. 457 tests on every change.
 EVIDENCE: E17 in docs/demo/evidence-ledger.md</a:t>
             </a:r>
             <a:endParaRPr lang="en-US" dirty="0"/>
@@ -982,9 +982,9 @@
               <a:rPr lang="en-US" dirty="0"/>
               <a:t>6:40–7:00 · Close
 ON SCREEN: Slide 14. Finish by 6:55.
-SAY (32 words):
-Ireland is turning clean power away. SaveThePlanet turns it into cheaper charging for drivers and new income for charging operators. Next, we want one operator to pilot it with us. Thank you.
-CAPTION: SaveThePlanet: cheaper EV charging from power Ireland would otherwise turn away.</a:t>
+SAY (35 words):
+Ireland is turning clean power away. SaveThePlanet turns it into cheaper charging for drivers, new income for charging operators, and surplus for hydrogen. Next, we want one operator to pilot it with us. Thank you.
+CAPTION: SaveThePlanet: cheaper EV charging, and surplus for hydrogen, from power Ireland would otherwise turn away.</a:t>
             </a:r>
             <a:endParaRPr lang="en-US" dirty="0"/>
           </a:p>
@@ -1259,11 +1259,11 @@
             <a:r>
               <a:rPr lang="en-US" dirty="0"/>
               <a:t>1:05–1:25 · The dashboard
-ON SCREEN: Slide 4 with recording 1 (Dashboard, 20 s): the historical target, the forecast, the battery routing, the EV plan.
-SAY (32 words):
-SaveThePlanet makes those four checks every half-hour. This is our dashboard, replaying a real half-hour from the past: the forecast, what the site's battery does with it, and which cars get charged.
-CAPTION: SaveThePlanet runs the four checks every half-hour.
-EVIDENCE: E3, E4 in docs/demo/evidence-ledger.md</a:t>
+ON SCREEN: Slide 4 with recording 1 (Dashboard, 20 s): the forecast, the EV plan and the battery level. If the battery shows FULL, point at the 'surplus to ESB hydrogen plants' line.
+SAY (44 words):
+SaveThePlanet makes those four checks every half-hour. This is our dashboard, replaying a real half-hour: the forecast, which cars get charged, and the grid battery filling up. Once the battery is full, the surplus goes towards ESB's hydrogen plants instead of being turned away.
+CAPTION: Every half-hour: the forecast, the cars, the battery. A full battery sends its surplus towards hydrogen (simulated).
+EVIDENCE: E3, E4, E18 in docs/demo/evidence-ledger.md</a:t>
             </a:r>
             <a:endParaRPr lang="en-US" dirty="0"/>
           </a:p>
@@ -3574,7 +3574,7 @@
                 <a:ea typeface="Arial" pitchFamily="34" charset="-122"/>
                 <a:cs typeface="Arial" pitchFamily="34" charset="-120"/>
               </a:rPr>
-              <a:t>Start with one Irish site. Then repeat it.</a:t>
+              <a:t>We grow as the EV market grows.</a:t>
             </a:r>
             <a:endParaRPr lang="en-US" sz="3400" dirty="0"/>
           </a:p>
@@ -3588,685 +3588,8 @@
         </p:nvSpPr>
         <p:spPr>
           <a:xfrm>
-            <a:off x="5532120" y="2011680"/>
-            <a:ext cx="1828800" cy="274320"/>
-          </a:xfrm>
-          <a:prstGeom prst="rect">
-            <a:avLst/>
-          </a:prstGeom>
-          <a:noFill/>
-          <a:ln/>
-        </p:spPr>
-        <p:txBody>
-          <a:bodyPr wrap="square" lIns="0" tIns="0" rIns="0" bIns="0" rtlCol="0" anchor="t"/>
-          <a:lstStyle/>
-          <a:p>
-            <a:pPr algn="r" indent="0" marL="0">
-              <a:buNone/>
-            </a:pPr>
-            <a:r>
-              <a:rPr lang="en-US" sz="1400" dirty="0">
-                <a:solidFill>
-                  <a:srgbClr val="8D9792"/>
-                </a:solidFill>
-                <a:latin typeface="Arial" pitchFamily="34" charset="0"/>
-                <a:ea typeface="Arial" pitchFamily="34" charset="-122"/>
-                <a:cs typeface="Arial" pitchFamily="34" charset="-120"/>
-              </a:rPr>
-              <a:t>1 site</a:t>
-            </a:r>
-            <a:endParaRPr lang="en-US" sz="1400" dirty="0"/>
-          </a:p>
-        </p:txBody>
-      </p:sp>
-      <p:sp>
-        <p:nvSpPr>
-          <p:cNvPr id="4" name="Text 2"/>
-          <p:cNvSpPr txBox="1"/>
-          <p:nvPr/>
-        </p:nvSpPr>
-        <p:spPr>
-          <a:xfrm>
-            <a:off x="7543800" y="2011680"/>
-            <a:ext cx="1828800" cy="274320"/>
-          </a:xfrm>
-          <a:prstGeom prst="rect">
-            <a:avLst/>
-          </a:prstGeom>
-          <a:noFill/>
-          <a:ln/>
-        </p:spPr>
-        <p:txBody>
-          <a:bodyPr wrap="square" lIns="0" tIns="0" rIns="0" bIns="0" rtlCol="0" anchor="t"/>
-          <a:lstStyle/>
-          <a:p>
-            <a:pPr algn="r" indent="0" marL="0">
-              <a:buNone/>
-            </a:pPr>
-            <a:r>
-              <a:rPr lang="en-US" sz="1400" dirty="0">
-                <a:solidFill>
-                  <a:srgbClr val="8D9792"/>
-                </a:solidFill>
-                <a:latin typeface="Arial" pitchFamily="34" charset="0"/>
-                <a:ea typeface="Arial" pitchFamily="34" charset="-122"/>
-                <a:cs typeface="Arial" pitchFamily="34" charset="-120"/>
-              </a:rPr>
-              <a:t>10 sites</a:t>
-            </a:r>
-            <a:endParaRPr lang="en-US" sz="1400" dirty="0"/>
-          </a:p>
-        </p:txBody>
-      </p:sp>
-      <p:sp>
-        <p:nvSpPr>
-          <p:cNvPr id="5" name="Text 3"/>
-          <p:cNvSpPr txBox="1"/>
-          <p:nvPr/>
-        </p:nvSpPr>
-        <p:spPr>
-          <a:xfrm>
-            <a:off x="9537192" y="2011680"/>
-            <a:ext cx="1828800" cy="274320"/>
-          </a:xfrm>
-          <a:prstGeom prst="rect">
-            <a:avLst/>
-          </a:prstGeom>
-          <a:noFill/>
-          <a:ln/>
-        </p:spPr>
-        <p:txBody>
-          <a:bodyPr wrap="square" lIns="0" tIns="0" rIns="0" bIns="0" rtlCol="0" anchor="t"/>
-          <a:lstStyle/>
-          <a:p>
-            <a:pPr algn="r" indent="0" marL="0">
-              <a:buNone/>
-            </a:pPr>
-            <a:r>
-              <a:rPr lang="en-US" sz="1400" dirty="0">
-                <a:solidFill>
-                  <a:srgbClr val="8D9792"/>
-                </a:solidFill>
-                <a:latin typeface="Arial" pitchFamily="34" charset="0"/>
-                <a:ea typeface="Arial" pitchFamily="34" charset="-122"/>
-                <a:cs typeface="Arial" pitchFamily="34" charset="-120"/>
-              </a:rPr>
-              <a:t>100 sites</a:t>
-            </a:r>
-            <a:endParaRPr lang="en-US" sz="1400" dirty="0"/>
-          </a:p>
-        </p:txBody>
-      </p:sp>
-      <p:sp>
-        <p:nvSpPr>
-          <p:cNvPr id="6" name="Shape 4"/>
-          <p:cNvSpPr/>
-          <p:nvPr/>
-        </p:nvSpPr>
-        <p:spPr>
-          <a:xfrm>
-            <a:off x="822960" y="2359152"/>
-            <a:ext cx="10545775" cy="0"/>
-          </a:xfrm>
-          <a:prstGeom prst="line">
-            <a:avLst/>
-          </a:prstGeom>
-          <a:noFill/>
-          <a:ln w="9525">
-            <a:solidFill>
-              <a:srgbClr val="DFE4E1"/>
-            </a:solidFill>
-            <a:prstDash val="solid"/>
-          </a:ln>
-        </p:spPr>
-      </p:sp>
-      <p:sp>
-        <p:nvSpPr>
-          <p:cNvPr id="7" name="Text 5"/>
-          <p:cNvSpPr txBox="1"/>
-          <p:nvPr/>
-        </p:nvSpPr>
-        <p:spPr>
-          <a:xfrm>
-            <a:off x="822960" y="2578608"/>
-            <a:ext cx="4572000" cy="365760"/>
-          </a:xfrm>
-          <a:prstGeom prst="rect">
-            <a:avLst/>
-          </a:prstGeom>
-          <a:noFill/>
-          <a:ln/>
-        </p:spPr>
-        <p:txBody>
-          <a:bodyPr wrap="square" lIns="0" tIns="0" rIns="0" bIns="0" rtlCol="0" anchor="t"/>
-          <a:lstStyle/>
-          <a:p>
-            <a:pPr indent="0" marL="0">
-              <a:buNone/>
-            </a:pPr>
-            <a:r>
-              <a:rPr lang="en-US" sz="1800" dirty="0">
-                <a:solidFill>
-                  <a:srgbClr val="5B6661"/>
-                </a:solidFill>
-                <a:latin typeface="Arial" pitchFamily="34" charset="0"/>
-                <a:ea typeface="Arial" pitchFamily="34" charset="-122"/>
-                <a:cs typeface="Arial" pitchFamily="34" charset="-120"/>
-              </a:rPr>
-              <a:t>Drivers save, a year</a:t>
-            </a:r>
-            <a:endParaRPr lang="en-US" sz="1800" dirty="0"/>
-          </a:p>
-        </p:txBody>
-      </p:sp>
-      <p:sp>
-        <p:nvSpPr>
-          <p:cNvPr id="8" name="Text 6"/>
-          <p:cNvSpPr txBox="1"/>
-          <p:nvPr/>
-        </p:nvSpPr>
-        <p:spPr>
-          <a:xfrm>
-            <a:off x="5532120" y="2468880"/>
-            <a:ext cx="1828800" cy="548640"/>
-          </a:xfrm>
-          <a:prstGeom prst="rect">
-            <a:avLst/>
-          </a:prstGeom>
-          <a:noFill/>
-          <a:ln/>
-        </p:spPr>
-        <p:txBody>
-          <a:bodyPr wrap="square" lIns="0" tIns="0" rIns="0" bIns="0" rtlCol="0" anchor="t"/>
-          <a:lstStyle/>
-          <a:p>
-            <a:pPr algn="r" indent="0" marL="0">
-              <a:buNone/>
-            </a:pPr>
-            <a:r>
-              <a:rPr lang="en-US" sz="3000" dirty="0">
-                <a:solidFill>
-                  <a:srgbClr val="5B6661"/>
-                </a:solidFill>
-                <a:latin typeface="Arial" pitchFamily="34" charset="0"/>
-                <a:ea typeface="Arial" pitchFamily="34" charset="-122"/>
-                <a:cs typeface="Arial" pitchFamily="34" charset="-120"/>
-              </a:rPr>
-              <a:t>€4,800</a:t>
-            </a:r>
-            <a:endParaRPr lang="en-US" sz="3000" dirty="0"/>
-          </a:p>
-        </p:txBody>
-      </p:sp>
-      <p:sp>
-        <p:nvSpPr>
-          <p:cNvPr id="9" name="Text 7"/>
-          <p:cNvSpPr txBox="1"/>
-          <p:nvPr/>
-        </p:nvSpPr>
-        <p:spPr>
-          <a:xfrm>
-            <a:off x="7543800" y="2468880"/>
-            <a:ext cx="1828800" cy="548640"/>
-          </a:xfrm>
-          <a:prstGeom prst="rect">
-            <a:avLst/>
-          </a:prstGeom>
-          <a:noFill/>
-          <a:ln/>
-        </p:spPr>
-        <p:txBody>
-          <a:bodyPr wrap="square" lIns="0" tIns="0" rIns="0" bIns="0" rtlCol="0" anchor="t"/>
-          <a:lstStyle/>
-          <a:p>
-            <a:pPr algn="r" indent="0" marL="0">
-              <a:buNone/>
-            </a:pPr>
-            <a:r>
-              <a:rPr lang="en-US" sz="3000" dirty="0">
-                <a:solidFill>
-                  <a:srgbClr val="5B6661"/>
-                </a:solidFill>
-                <a:latin typeface="Arial" pitchFamily="34" charset="0"/>
-                <a:ea typeface="Arial" pitchFamily="34" charset="-122"/>
-                <a:cs typeface="Arial" pitchFamily="34" charset="-120"/>
-              </a:rPr>
-              <a:t>€48,000</a:t>
-            </a:r>
-            <a:endParaRPr lang="en-US" sz="3000" dirty="0"/>
-          </a:p>
-        </p:txBody>
-      </p:sp>
-      <p:sp>
-        <p:nvSpPr>
-          <p:cNvPr id="10" name="Text 8"/>
-          <p:cNvSpPr txBox="1"/>
-          <p:nvPr/>
-        </p:nvSpPr>
-        <p:spPr>
-          <a:xfrm>
-            <a:off x="9537192" y="2468880"/>
-            <a:ext cx="1828800" cy="548640"/>
-          </a:xfrm>
-          <a:prstGeom prst="rect">
-            <a:avLst/>
-          </a:prstGeom>
-          <a:noFill/>
-          <a:ln/>
-        </p:spPr>
-        <p:txBody>
-          <a:bodyPr wrap="square" lIns="0" tIns="0" rIns="0" bIns="0" rtlCol="0" anchor="t"/>
-          <a:lstStyle/>
-          <a:p>
-            <a:pPr algn="r" indent="0" marL="0">
-              <a:buNone/>
-            </a:pPr>
-            <a:r>
-              <a:rPr lang="en-US" sz="3000" b="1" dirty="0">
-                <a:solidFill>
-                  <a:srgbClr val="17201C"/>
-                </a:solidFill>
-                <a:latin typeface="Arial" pitchFamily="34" charset="0"/>
-                <a:ea typeface="Arial" pitchFamily="34" charset="-122"/>
-                <a:cs typeface="Arial" pitchFamily="34" charset="-120"/>
-              </a:rPr>
-              <a:t>€480,000</a:t>
-            </a:r>
-            <a:endParaRPr lang="en-US" sz="3000" dirty="0"/>
-          </a:p>
-        </p:txBody>
-      </p:sp>
-      <p:sp>
-        <p:nvSpPr>
-          <p:cNvPr id="11" name="Shape 9"/>
-          <p:cNvSpPr/>
-          <p:nvPr/>
-        </p:nvSpPr>
-        <p:spPr>
-          <a:xfrm>
-            <a:off x="822960" y="3273552"/>
-            <a:ext cx="10545775" cy="0"/>
-          </a:xfrm>
-          <a:prstGeom prst="line">
-            <a:avLst/>
-          </a:prstGeom>
-          <a:noFill/>
-          <a:ln w="9525">
-            <a:solidFill>
-              <a:srgbClr val="DFE4E1"/>
-            </a:solidFill>
-            <a:prstDash val="solid"/>
-          </a:ln>
-        </p:spPr>
-      </p:sp>
-      <p:sp>
-        <p:nvSpPr>
-          <p:cNvPr id="12" name="Text 10"/>
-          <p:cNvSpPr txBox="1"/>
-          <p:nvPr/>
-        </p:nvSpPr>
-        <p:spPr>
-          <a:xfrm>
-            <a:off x="822960" y="3493008"/>
-            <a:ext cx="4572000" cy="365760"/>
-          </a:xfrm>
-          <a:prstGeom prst="rect">
-            <a:avLst/>
-          </a:prstGeom>
-          <a:noFill/>
-          <a:ln/>
-        </p:spPr>
-        <p:txBody>
-          <a:bodyPr wrap="square" lIns="0" tIns="0" rIns="0" bIns="0" rtlCol="0" anchor="t"/>
-          <a:lstStyle/>
-          <a:p>
-            <a:pPr indent="0" marL="0">
-              <a:buNone/>
-            </a:pPr>
-            <a:r>
-              <a:rPr lang="en-US" sz="1800" dirty="0">
-                <a:solidFill>
-                  <a:srgbClr val="5B6661"/>
-                </a:solidFill>
-                <a:latin typeface="Arial" pitchFamily="34" charset="0"/>
-                <a:ea typeface="Arial" pitchFamily="34" charset="-122"/>
-                <a:cs typeface="Arial" pitchFamily="34" charset="-120"/>
-              </a:rPr>
-              <a:t>Operators earn, a year</a:t>
-            </a:r>
-            <a:endParaRPr lang="en-US" sz="1800" dirty="0"/>
-          </a:p>
-        </p:txBody>
-      </p:sp>
-      <p:sp>
-        <p:nvSpPr>
-          <p:cNvPr id="13" name="Text 11"/>
-          <p:cNvSpPr txBox="1"/>
-          <p:nvPr/>
-        </p:nvSpPr>
-        <p:spPr>
-          <a:xfrm>
-            <a:off x="5532120" y="3383280"/>
-            <a:ext cx="1828800" cy="548640"/>
-          </a:xfrm>
-          <a:prstGeom prst="rect">
-            <a:avLst/>
-          </a:prstGeom>
-          <a:noFill/>
-          <a:ln/>
-        </p:spPr>
-        <p:txBody>
-          <a:bodyPr wrap="square" lIns="0" tIns="0" rIns="0" bIns="0" rtlCol="0" anchor="t"/>
-          <a:lstStyle/>
-          <a:p>
-            <a:pPr algn="r" indent="0" marL="0">
-              <a:buNone/>
-            </a:pPr>
-            <a:r>
-              <a:rPr lang="en-US" sz="3000" dirty="0">
-                <a:solidFill>
-                  <a:srgbClr val="5B6661"/>
-                </a:solidFill>
-                <a:latin typeface="Arial" pitchFamily="34" charset="0"/>
-                <a:ea typeface="Arial" pitchFamily="34" charset="-122"/>
-                <a:cs typeface="Arial" pitchFamily="34" charset="-120"/>
-              </a:rPr>
-              <a:t>€1,200</a:t>
-            </a:r>
-            <a:endParaRPr lang="en-US" sz="3000" dirty="0"/>
-          </a:p>
-        </p:txBody>
-      </p:sp>
-      <p:sp>
-        <p:nvSpPr>
-          <p:cNvPr id="14" name="Text 12"/>
-          <p:cNvSpPr txBox="1"/>
-          <p:nvPr/>
-        </p:nvSpPr>
-        <p:spPr>
-          <a:xfrm>
-            <a:off x="7543800" y="3383280"/>
-            <a:ext cx="1828800" cy="548640"/>
-          </a:xfrm>
-          <a:prstGeom prst="rect">
-            <a:avLst/>
-          </a:prstGeom>
-          <a:noFill/>
-          <a:ln/>
-        </p:spPr>
-        <p:txBody>
-          <a:bodyPr wrap="square" lIns="0" tIns="0" rIns="0" bIns="0" rtlCol="0" anchor="t"/>
-          <a:lstStyle/>
-          <a:p>
-            <a:pPr algn="r" indent="0" marL="0">
-              <a:buNone/>
-            </a:pPr>
-            <a:r>
-              <a:rPr lang="en-US" sz="3000" dirty="0">
-                <a:solidFill>
-                  <a:srgbClr val="5B6661"/>
-                </a:solidFill>
-                <a:latin typeface="Arial" pitchFamily="34" charset="0"/>
-                <a:ea typeface="Arial" pitchFamily="34" charset="-122"/>
-                <a:cs typeface="Arial" pitchFamily="34" charset="-120"/>
-              </a:rPr>
-              <a:t>€12,000</a:t>
-            </a:r>
-            <a:endParaRPr lang="en-US" sz="3000" dirty="0"/>
-          </a:p>
-        </p:txBody>
-      </p:sp>
-      <p:sp>
-        <p:nvSpPr>
-          <p:cNvPr id="15" name="Text 13"/>
-          <p:cNvSpPr txBox="1"/>
-          <p:nvPr/>
-        </p:nvSpPr>
-        <p:spPr>
-          <a:xfrm>
-            <a:off x="9537192" y="3383280"/>
-            <a:ext cx="1828800" cy="548640"/>
-          </a:xfrm>
-          <a:prstGeom prst="rect">
-            <a:avLst/>
-          </a:prstGeom>
-          <a:noFill/>
-          <a:ln/>
-        </p:spPr>
-        <p:txBody>
-          <a:bodyPr wrap="square" lIns="0" tIns="0" rIns="0" bIns="0" rtlCol="0" anchor="t"/>
-          <a:lstStyle/>
-          <a:p>
-            <a:pPr algn="r" indent="0" marL="0">
-              <a:buNone/>
-            </a:pPr>
-            <a:r>
-              <a:rPr lang="en-US" sz="3000" b="1" dirty="0">
-                <a:solidFill>
-                  <a:srgbClr val="17201C"/>
-                </a:solidFill>
-                <a:latin typeface="Arial" pitchFamily="34" charset="0"/>
-                <a:ea typeface="Arial" pitchFamily="34" charset="-122"/>
-                <a:cs typeface="Arial" pitchFamily="34" charset="-120"/>
-              </a:rPr>
-              <a:t>€120,000</a:t>
-            </a:r>
-            <a:endParaRPr lang="en-US" sz="3000" dirty="0"/>
-          </a:p>
-        </p:txBody>
-      </p:sp>
-      <p:sp>
-        <p:nvSpPr>
-          <p:cNvPr id="16" name="Shape 14"/>
-          <p:cNvSpPr/>
-          <p:nvPr/>
-        </p:nvSpPr>
-        <p:spPr>
-          <a:xfrm>
-            <a:off x="822960" y="4187952"/>
-            <a:ext cx="10545775" cy="0"/>
-          </a:xfrm>
-          <a:prstGeom prst="line">
-            <a:avLst/>
-          </a:prstGeom>
-          <a:noFill/>
-          <a:ln w="9525">
-            <a:solidFill>
-              <a:srgbClr val="DFE4E1"/>
-            </a:solidFill>
-            <a:prstDash val="solid"/>
-          </a:ln>
-        </p:spPr>
-      </p:sp>
-      <p:sp>
-        <p:nvSpPr>
-          <p:cNvPr id="17" name="Text 15"/>
-          <p:cNvSpPr txBox="1"/>
-          <p:nvPr/>
-        </p:nvSpPr>
-        <p:spPr>
-          <a:xfrm>
-            <a:off x="822960" y="4407408"/>
-            <a:ext cx="4572000" cy="365760"/>
-          </a:xfrm>
-          <a:prstGeom prst="rect">
-            <a:avLst/>
-          </a:prstGeom>
-          <a:noFill/>
-          <a:ln/>
-        </p:spPr>
-        <p:txBody>
-          <a:bodyPr wrap="square" lIns="0" tIns="0" rIns="0" bIns="0" rtlCol="0" anchor="t"/>
-          <a:lstStyle/>
-          <a:p>
-            <a:pPr indent="0" marL="0">
-              <a:buNone/>
-            </a:pPr>
-            <a:r>
-              <a:rPr lang="en-US" sz="1800" dirty="0">
-                <a:solidFill>
-                  <a:srgbClr val="5B6661"/>
-                </a:solidFill>
-                <a:latin typeface="Arial" pitchFamily="34" charset="0"/>
-                <a:ea typeface="Arial" pitchFamily="34" charset="-122"/>
-                <a:cs typeface="Arial" pitchFamily="34" charset="-120"/>
-              </a:rPr>
-              <a:t>CO₂ avoided, a year (estimate)</a:t>
-            </a:r>
-            <a:endParaRPr lang="en-US" sz="1800" dirty="0"/>
-          </a:p>
-        </p:txBody>
-      </p:sp>
-      <p:sp>
-        <p:nvSpPr>
-          <p:cNvPr id="18" name="Text 16"/>
-          <p:cNvSpPr txBox="1"/>
-          <p:nvPr/>
-        </p:nvSpPr>
-        <p:spPr>
-          <a:xfrm>
-            <a:off x="5532120" y="4297680"/>
-            <a:ext cx="1828800" cy="548640"/>
-          </a:xfrm>
-          <a:prstGeom prst="rect">
-            <a:avLst/>
-          </a:prstGeom>
-          <a:noFill/>
-          <a:ln/>
-        </p:spPr>
-        <p:txBody>
-          <a:bodyPr wrap="square" lIns="0" tIns="0" rIns="0" bIns="0" rtlCol="0" anchor="t"/>
-          <a:lstStyle/>
-          <a:p>
-            <a:pPr algn="r" indent="0" marL="0">
-              <a:buNone/>
-            </a:pPr>
-            <a:r>
-              <a:rPr lang="en-US" sz="3000" dirty="0">
-                <a:solidFill>
-                  <a:srgbClr val="5B6661"/>
-                </a:solidFill>
-                <a:latin typeface="Arial" pitchFamily="34" charset="0"/>
-                <a:ea typeface="Arial" pitchFamily="34" charset="-122"/>
-                <a:cs typeface="Arial" pitchFamily="34" charset="-120"/>
-              </a:rPr>
-              <a:t>24 t</a:t>
-            </a:r>
-            <a:endParaRPr lang="en-US" sz="3000" dirty="0"/>
-          </a:p>
-        </p:txBody>
-      </p:sp>
-      <p:sp>
-        <p:nvSpPr>
-          <p:cNvPr id="19" name="Text 17"/>
-          <p:cNvSpPr txBox="1"/>
-          <p:nvPr/>
-        </p:nvSpPr>
-        <p:spPr>
-          <a:xfrm>
-            <a:off x="7543800" y="4297680"/>
-            <a:ext cx="1828800" cy="548640"/>
-          </a:xfrm>
-          <a:prstGeom prst="rect">
-            <a:avLst/>
-          </a:prstGeom>
-          <a:noFill/>
-          <a:ln/>
-        </p:spPr>
-        <p:txBody>
-          <a:bodyPr wrap="square" lIns="0" tIns="0" rIns="0" bIns="0" rtlCol="0" anchor="t"/>
-          <a:lstStyle/>
-          <a:p>
-            <a:pPr algn="r" indent="0" marL="0">
-              <a:buNone/>
-            </a:pPr>
-            <a:r>
-              <a:rPr lang="en-US" sz="3000" dirty="0">
-                <a:solidFill>
-                  <a:srgbClr val="5B6661"/>
-                </a:solidFill>
-                <a:latin typeface="Arial" pitchFamily="34" charset="0"/>
-                <a:ea typeface="Arial" pitchFamily="34" charset="-122"/>
-                <a:cs typeface="Arial" pitchFamily="34" charset="-120"/>
-              </a:rPr>
-              <a:t>240 t</a:t>
-            </a:r>
-            <a:endParaRPr lang="en-US" sz="3000" dirty="0"/>
-          </a:p>
-        </p:txBody>
-      </p:sp>
-      <p:sp>
-        <p:nvSpPr>
-          <p:cNvPr id="20" name="Text 18"/>
-          <p:cNvSpPr txBox="1"/>
-          <p:nvPr/>
-        </p:nvSpPr>
-        <p:spPr>
-          <a:xfrm>
-            <a:off x="9537192" y="4297680"/>
-            <a:ext cx="1828800" cy="548640"/>
-          </a:xfrm>
-          <a:prstGeom prst="rect">
-            <a:avLst/>
-          </a:prstGeom>
-          <a:noFill/>
-          <a:ln/>
-        </p:spPr>
-        <p:txBody>
-          <a:bodyPr wrap="square" lIns="0" tIns="0" rIns="0" bIns="0" rtlCol="0" anchor="t"/>
-          <a:lstStyle/>
-          <a:p>
-            <a:pPr algn="r" indent="0" marL="0">
-              <a:buNone/>
-            </a:pPr>
-            <a:r>
-              <a:rPr lang="en-US" sz="3000" b="1" dirty="0">
-                <a:solidFill>
-                  <a:srgbClr val="17201C"/>
-                </a:solidFill>
-                <a:latin typeface="Arial" pitchFamily="34" charset="0"/>
-                <a:ea typeface="Arial" pitchFamily="34" charset="-122"/>
-                <a:cs typeface="Arial" pitchFamily="34" charset="-120"/>
-              </a:rPr>
-              <a:t>2,400 t</a:t>
-            </a:r>
-            <a:endParaRPr lang="en-US" sz="3000" dirty="0"/>
-          </a:p>
-        </p:txBody>
-      </p:sp>
-      <p:sp>
-        <p:nvSpPr>
-          <p:cNvPr id="21" name="Shape 19"/>
-          <p:cNvSpPr/>
-          <p:nvPr/>
-        </p:nvSpPr>
-        <p:spPr>
-          <a:xfrm>
-            <a:off x="822960" y="5102352"/>
-            <a:ext cx="10545775" cy="0"/>
-          </a:xfrm>
-          <a:prstGeom prst="line">
-            <a:avLst/>
-          </a:prstGeom>
-          <a:noFill/>
-          <a:ln w="9525">
-            <a:solidFill>
-              <a:srgbClr val="DFE4E1"/>
-            </a:solidFill>
-            <a:prstDash val="solid"/>
-          </a:ln>
-        </p:spPr>
-      </p:sp>
-      <p:sp>
-        <p:nvSpPr>
-          <p:cNvPr id="22" name="Text 20"/>
-          <p:cNvSpPr txBox="1"/>
-          <p:nvPr/>
-        </p:nvSpPr>
-        <p:spPr>
-          <a:xfrm>
-            <a:off x="822960" y="5303520"/>
-            <a:ext cx="10545775" cy="365760"/>
+            <a:off x="822960" y="1298448"/>
+            <a:ext cx="10545775" cy="640080"/>
           </a:xfrm>
           <a:prstGeom prst="rect">
             <a:avLst/>
@@ -4290,7 +3613,7 @@
                 <a:ea typeface="Arial" pitchFamily="34" charset="-122"/>
                 <a:cs typeface="Arial" pitchFamily="34" charset="-120"/>
               </a:rPr>
-              <a:t>Each country needs its own grid data, model training and tariffs. Other European grids turn away power too.</a:t>
+              <a:t>Where the spare power our sites can reach would go: 194.6 MWh in one replayed week, 24–31 January 2026.</a:t>
             </a:r>
             <a:endParaRPr lang="en-US" sz="1600" dirty="0"/>
           </a:p>
@@ -4298,7 +3621,1334 @@
       </p:sp>
       <p:sp>
         <p:nvSpPr>
+          <p:cNvPr id="4" name="Shape 2"/>
+          <p:cNvSpPr/>
+          <p:nvPr/>
+        </p:nvSpPr>
+        <p:spPr>
+          <a:xfrm>
+            <a:off x="3886200" y="2148840"/>
+            <a:ext cx="128016" cy="128016"/>
+          </a:xfrm>
+          <a:prstGeom prst="rect">
+            <a:avLst/>
+          </a:prstGeom>
+          <a:solidFill>
+            <a:srgbClr val="0E8A62"/>
+          </a:solidFill>
+          <a:ln w="12700">
+            <a:solidFill>
+              <a:srgbClr val="0E8A62"/>
+            </a:solidFill>
+            <a:prstDash val="solid"/>
+          </a:ln>
+        </p:spPr>
+      </p:sp>
+      <p:sp>
+        <p:nvSpPr>
+          <p:cNvPr id="5" name="Text 3"/>
+          <p:cNvSpPr txBox="1"/>
+          <p:nvPr/>
+        </p:nvSpPr>
+        <p:spPr>
+          <a:xfrm>
+            <a:off x="4087368" y="2103120"/>
+            <a:ext cx="1463040" cy="219456"/>
+          </a:xfrm>
+          <a:prstGeom prst="rect">
+            <a:avLst/>
+          </a:prstGeom>
+          <a:noFill/>
+          <a:ln/>
+        </p:spPr>
+        <p:txBody>
+          <a:bodyPr wrap="square" lIns="0" tIns="0" rIns="0" bIns="0" rtlCol="0" anchor="t"/>
+          <a:lstStyle/>
+          <a:p>
+            <a:pPr indent="0" marL="0">
+              <a:buNone/>
+            </a:pPr>
+            <a:r>
+              <a:rPr lang="en-US" sz="1200" dirty="0">
+                <a:solidFill>
+                  <a:srgbClr val="5B6661"/>
+                </a:solidFill>
+                <a:latin typeface="Arial" pitchFamily="34" charset="0"/>
+                <a:ea typeface="Arial" pitchFamily="34" charset="-122"/>
+                <a:cs typeface="Arial" pitchFamily="34" charset="-120"/>
+              </a:rPr>
+              <a:t>EV charging</a:t>
+            </a:r>
+            <a:endParaRPr lang="en-US" sz="1200" dirty="0"/>
+          </a:p>
+        </p:txBody>
+      </p:sp>
+      <p:sp>
+        <p:nvSpPr>
+          <p:cNvPr id="6" name="Shape 4"/>
+          <p:cNvSpPr/>
+          <p:nvPr/>
+        </p:nvSpPr>
+        <p:spPr>
+          <a:xfrm>
+            <a:off x="5623560" y="2148840"/>
+            <a:ext cx="128016" cy="128016"/>
+          </a:xfrm>
+          <a:prstGeom prst="rect">
+            <a:avLst/>
+          </a:prstGeom>
+          <a:solidFill>
+            <a:srgbClr val="D48F0F"/>
+          </a:solidFill>
+          <a:ln w="12700">
+            <a:solidFill>
+              <a:srgbClr val="D48F0F"/>
+            </a:solidFill>
+            <a:prstDash val="solid"/>
+          </a:ln>
+        </p:spPr>
+      </p:sp>
+      <p:sp>
+        <p:nvSpPr>
+          <p:cNvPr id="7" name="Text 5"/>
+          <p:cNvSpPr txBox="1"/>
+          <p:nvPr/>
+        </p:nvSpPr>
+        <p:spPr>
+          <a:xfrm>
+            <a:off x="5824728" y="2103120"/>
+            <a:ext cx="1463040" cy="219456"/>
+          </a:xfrm>
+          <a:prstGeom prst="rect">
+            <a:avLst/>
+          </a:prstGeom>
+          <a:noFill/>
+          <a:ln/>
+        </p:spPr>
+        <p:txBody>
+          <a:bodyPr wrap="square" lIns="0" tIns="0" rIns="0" bIns="0" rtlCol="0" anchor="t"/>
+          <a:lstStyle/>
+          <a:p>
+            <a:pPr indent="0" marL="0">
+              <a:buNone/>
+            </a:pPr>
+            <a:r>
+              <a:rPr lang="en-US" sz="1200" dirty="0">
+                <a:solidFill>
+                  <a:srgbClr val="5B6661"/>
+                </a:solidFill>
+                <a:latin typeface="Arial" pitchFamily="34" charset="0"/>
+                <a:ea typeface="Arial" pitchFamily="34" charset="-122"/>
+                <a:cs typeface="Arial" pitchFamily="34" charset="-120"/>
+              </a:rPr>
+              <a:t>Grid battery</a:t>
+            </a:r>
+            <a:endParaRPr lang="en-US" sz="1200" dirty="0"/>
+          </a:p>
+        </p:txBody>
+      </p:sp>
+      <p:sp>
+        <p:nvSpPr>
+          <p:cNvPr id="8" name="Shape 6"/>
+          <p:cNvSpPr/>
+          <p:nvPr/>
+        </p:nvSpPr>
+        <p:spPr>
+          <a:xfrm>
+            <a:off x="7360920" y="2148840"/>
+            <a:ext cx="128016" cy="128016"/>
+          </a:xfrm>
+          <a:prstGeom prst="rect">
+            <a:avLst/>
+          </a:prstGeom>
+          <a:solidFill>
+            <a:srgbClr val="6F4FE8"/>
+          </a:solidFill>
+          <a:ln w="12700">
+            <a:solidFill>
+              <a:srgbClr val="6F4FE8"/>
+            </a:solidFill>
+            <a:prstDash val="solid"/>
+          </a:ln>
+        </p:spPr>
+      </p:sp>
+      <p:sp>
+        <p:nvSpPr>
+          <p:cNvPr id="9" name="Text 7"/>
+          <p:cNvSpPr txBox="1"/>
+          <p:nvPr/>
+        </p:nvSpPr>
+        <p:spPr>
+          <a:xfrm>
+            <a:off x="7562088" y="2103120"/>
+            <a:ext cx="1463040" cy="219456"/>
+          </a:xfrm>
+          <a:prstGeom prst="rect">
+            <a:avLst/>
+          </a:prstGeom>
+          <a:noFill/>
+          <a:ln/>
+        </p:spPr>
+        <p:txBody>
+          <a:bodyPr wrap="square" lIns="0" tIns="0" rIns="0" bIns="0" rtlCol="0" anchor="t"/>
+          <a:lstStyle/>
+          <a:p>
+            <a:pPr indent="0" marL="0">
+              <a:buNone/>
+            </a:pPr>
+            <a:r>
+              <a:rPr lang="en-US" sz="1200" dirty="0">
+                <a:solidFill>
+                  <a:srgbClr val="5B6661"/>
+                </a:solidFill>
+                <a:latin typeface="Arial" pitchFamily="34" charset="0"/>
+                <a:ea typeface="Arial" pitchFamily="34" charset="-122"/>
+                <a:cs typeface="Arial" pitchFamily="34" charset="-120"/>
+              </a:rPr>
+              <a:t>Hydrogen</a:t>
+            </a:r>
+            <a:endParaRPr lang="en-US" sz="1200" dirty="0"/>
+          </a:p>
+        </p:txBody>
+      </p:sp>
+      <p:sp>
+        <p:nvSpPr>
+          <p:cNvPr id="10" name="Shape 8"/>
+          <p:cNvSpPr/>
+          <p:nvPr/>
+        </p:nvSpPr>
+        <p:spPr>
+          <a:xfrm>
+            <a:off x="9098280" y="2148840"/>
+            <a:ext cx="128016" cy="128016"/>
+          </a:xfrm>
+          <a:prstGeom prst="rect">
+            <a:avLst/>
+          </a:prstGeom>
+          <a:solidFill>
+            <a:srgbClr val="E9EDEB"/>
+          </a:solidFill>
+          <a:ln w="12700">
+            <a:solidFill>
+              <a:srgbClr val="E9EDEB"/>
+            </a:solidFill>
+            <a:prstDash val="solid"/>
+          </a:ln>
+        </p:spPr>
+      </p:sp>
+      <p:sp>
+        <p:nvSpPr>
+          <p:cNvPr id="11" name="Text 9"/>
+          <p:cNvSpPr txBox="1"/>
+          <p:nvPr/>
+        </p:nvSpPr>
+        <p:spPr>
+          <a:xfrm>
+            <a:off x="9299448" y="2103120"/>
+            <a:ext cx="1463040" cy="219456"/>
+          </a:xfrm>
+          <a:prstGeom prst="rect">
+            <a:avLst/>
+          </a:prstGeom>
+          <a:noFill/>
+          <a:ln/>
+        </p:spPr>
+        <p:txBody>
+          <a:bodyPr wrap="square" lIns="0" tIns="0" rIns="0" bIns="0" rtlCol="0" anchor="t"/>
+          <a:lstStyle/>
+          <a:p>
+            <a:pPr indent="0" marL="0">
+              <a:buNone/>
+            </a:pPr>
+            <a:r>
+              <a:rPr lang="en-US" sz="1200" dirty="0">
+                <a:solidFill>
+                  <a:srgbClr val="5B6661"/>
+                </a:solidFill>
+                <a:latin typeface="Arial" pitchFamily="34" charset="0"/>
+                <a:ea typeface="Arial" pitchFamily="34" charset="-122"/>
+                <a:cs typeface="Arial" pitchFamily="34" charset="-120"/>
+              </a:rPr>
+              <a:t>Unused</a:t>
+            </a:r>
+            <a:endParaRPr lang="en-US" sz="1200" dirty="0"/>
+          </a:p>
+        </p:txBody>
+      </p:sp>
+      <p:sp>
+        <p:nvSpPr>
+          <p:cNvPr id="12" name="Text 10"/>
+          <p:cNvSpPr txBox="1"/>
+          <p:nvPr/>
+        </p:nvSpPr>
+        <p:spPr>
+          <a:xfrm>
+            <a:off x="822960" y="2679192"/>
+            <a:ext cx="2880360" cy="320040"/>
+          </a:xfrm>
+          <a:prstGeom prst="rect">
+            <a:avLst/>
+          </a:prstGeom>
+          <a:noFill/>
+          <a:ln/>
+        </p:spPr>
+        <p:txBody>
+          <a:bodyPr wrap="square" lIns="0" tIns="0" rIns="0" bIns="0" rtlCol="0" anchor="t"/>
+          <a:lstStyle/>
+          <a:p>
+            <a:pPr indent="0" marL="0">
+              <a:buNone/>
+            </a:pPr>
+            <a:r>
+              <a:rPr lang="en-US" sz="1800" b="1" dirty="0">
+                <a:solidFill>
+                  <a:srgbClr val="17201C"/>
+                </a:solidFill>
+                <a:latin typeface="Arial" pitchFamily="34" charset="0"/>
+                <a:ea typeface="Arial" pitchFamily="34" charset="-122"/>
+                <a:cs typeface="Arial" pitchFamily="34" charset="-120"/>
+              </a:rPr>
+              <a:t>Pilot</a:t>
+            </a:r>
+            <a:endParaRPr lang="en-US" sz="1800" dirty="0"/>
+          </a:p>
+        </p:txBody>
+      </p:sp>
+      <p:sp>
+        <p:nvSpPr>
+          <p:cNvPr id="13" name="Text 11"/>
+          <p:cNvSpPr txBox="1"/>
+          <p:nvPr/>
+        </p:nvSpPr>
+        <p:spPr>
+          <a:xfrm>
+            <a:off x="822960" y="3026664"/>
+            <a:ext cx="2880360" cy="256032"/>
+          </a:xfrm>
+          <a:prstGeom prst="rect">
+            <a:avLst/>
+          </a:prstGeom>
+          <a:noFill/>
+          <a:ln/>
+        </p:spPr>
+        <p:txBody>
+          <a:bodyPr wrap="square" lIns="0" tIns="0" rIns="0" bIns="0" rtlCol="0" anchor="t"/>
+          <a:lstStyle/>
+          <a:p>
+            <a:pPr indent="0" marL="0">
+              <a:buNone/>
+            </a:pPr>
+            <a:r>
+              <a:rPr lang="en-US" sz="1200" dirty="0">
+                <a:solidFill>
+                  <a:srgbClr val="8D9792"/>
+                </a:solidFill>
+                <a:latin typeface="Arial" pitchFamily="34" charset="0"/>
+                <a:ea typeface="Arial" pitchFamily="34" charset="-122"/>
+                <a:cs typeface="Arial" pitchFamily="34" charset="-120"/>
+              </a:rPr>
+              <a:t>200 EVs</a:t>
+            </a:r>
+            <a:endParaRPr lang="en-US" sz="1200" dirty="0"/>
+          </a:p>
+        </p:txBody>
+      </p:sp>
+      <p:sp>
+        <p:nvSpPr>
+          <p:cNvPr id="14" name="Shape 12"/>
+          <p:cNvSpPr/>
+          <p:nvPr/>
+        </p:nvSpPr>
+        <p:spPr>
+          <a:xfrm>
+            <a:off x="3886200" y="2697480"/>
+            <a:ext cx="1687857" cy="502920"/>
+          </a:xfrm>
+          <a:prstGeom prst="rect">
+            <a:avLst/>
+          </a:prstGeom>
+          <a:solidFill>
+            <a:srgbClr val="0E8A62"/>
+          </a:solidFill>
+          <a:ln w="12700">
+            <a:solidFill>
+              <a:srgbClr val="0E8A62"/>
+            </a:solidFill>
+            <a:prstDash val="solid"/>
+          </a:ln>
+        </p:spPr>
+      </p:sp>
+      <p:sp>
+        <p:nvSpPr>
+          <p:cNvPr id="15" name="Text 13"/>
+          <p:cNvSpPr txBox="1"/>
+          <p:nvPr/>
+        </p:nvSpPr>
+        <p:spPr>
+          <a:xfrm>
+            <a:off x="3886200" y="2807208"/>
+            <a:ext cx="1687857" cy="274320"/>
+          </a:xfrm>
+          <a:prstGeom prst="rect">
+            <a:avLst/>
+          </a:prstGeom>
+          <a:noFill/>
+          <a:ln/>
+        </p:spPr>
+        <p:txBody>
+          <a:bodyPr wrap="square" lIns="0" tIns="0" rIns="0" bIns="0" rtlCol="0" anchor="t"/>
+          <a:lstStyle/>
+          <a:p>
+            <a:pPr algn="ctr" indent="0" marL="0">
+              <a:buNone/>
+            </a:pPr>
+            <a:r>
+              <a:rPr lang="en-US" sz="1400" b="1" dirty="0">
+                <a:solidFill>
+                  <a:srgbClr val="FFFFFF"/>
+                </a:solidFill>
+                <a:latin typeface="Arial" pitchFamily="34" charset="0"/>
+                <a:ea typeface="Arial" pitchFamily="34" charset="-122"/>
+                <a:cs typeface="Arial" pitchFamily="34" charset="-120"/>
+              </a:rPr>
+              <a:t>29%</a:t>
+            </a:r>
+            <a:endParaRPr lang="en-US" sz="1400" dirty="0"/>
+          </a:p>
+        </p:txBody>
+      </p:sp>
+      <p:sp>
+        <p:nvSpPr>
+          <p:cNvPr id="16" name="Shape 14"/>
+          <p:cNvSpPr/>
+          <p:nvPr/>
+        </p:nvSpPr>
+        <p:spPr>
+          <a:xfrm>
+            <a:off x="5601489" y="2697480"/>
+            <a:ext cx="174332" cy="502920"/>
+          </a:xfrm>
+          <a:prstGeom prst="rect">
+            <a:avLst/>
+          </a:prstGeom>
+          <a:solidFill>
+            <a:srgbClr val="D48F0F"/>
+          </a:solidFill>
+          <a:ln w="12700">
+            <a:solidFill>
+              <a:srgbClr val="D48F0F"/>
+            </a:solidFill>
+            <a:prstDash val="solid"/>
+          </a:ln>
+        </p:spPr>
+      </p:sp>
+      <p:sp>
+        <p:nvSpPr>
+          <p:cNvPr id="17" name="Shape 15"/>
+          <p:cNvSpPr/>
+          <p:nvPr/>
+        </p:nvSpPr>
+        <p:spPr>
+          <a:xfrm>
+            <a:off x="5803253" y="2697480"/>
+            <a:ext cx="2802559" cy="502920"/>
+          </a:xfrm>
+          <a:prstGeom prst="rect">
+            <a:avLst/>
+          </a:prstGeom>
+          <a:solidFill>
+            <a:srgbClr val="6F4FE8"/>
+          </a:solidFill>
+          <a:ln w="12700">
+            <a:solidFill>
+              <a:srgbClr val="6F4FE8"/>
+            </a:solidFill>
+            <a:prstDash val="solid"/>
+          </a:ln>
+        </p:spPr>
+      </p:sp>
+      <p:sp>
+        <p:nvSpPr>
+          <p:cNvPr id="18" name="Text 16"/>
+          <p:cNvSpPr txBox="1"/>
+          <p:nvPr/>
+        </p:nvSpPr>
+        <p:spPr>
+          <a:xfrm>
+            <a:off x="5803253" y="2807208"/>
+            <a:ext cx="2802559" cy="274320"/>
+          </a:xfrm>
+          <a:prstGeom prst="rect">
+            <a:avLst/>
+          </a:prstGeom>
+          <a:noFill/>
+          <a:ln/>
+        </p:spPr>
+        <p:txBody>
+          <a:bodyPr wrap="square" lIns="0" tIns="0" rIns="0" bIns="0" rtlCol="0" anchor="t"/>
+          <a:lstStyle/>
+          <a:p>
+            <a:pPr algn="ctr" indent="0" marL="0">
+              <a:buNone/>
+            </a:pPr>
+            <a:r>
+              <a:rPr lang="en-US" sz="1400" b="1" dirty="0">
+                <a:solidFill>
+                  <a:srgbClr val="FFFFFF"/>
+                </a:solidFill>
+                <a:latin typeface="Arial" pitchFamily="34" charset="0"/>
+                <a:ea typeface="Arial" pitchFamily="34" charset="-122"/>
+                <a:cs typeface="Arial" pitchFamily="34" charset="-120"/>
+              </a:rPr>
+              <a:t>48%</a:t>
+            </a:r>
+            <a:endParaRPr lang="en-US" sz="1400" dirty="0"/>
+          </a:p>
+        </p:txBody>
+      </p:sp>
+      <p:sp>
+        <p:nvSpPr>
+          <p:cNvPr id="19" name="Shape 17"/>
+          <p:cNvSpPr/>
+          <p:nvPr/>
+        </p:nvSpPr>
+        <p:spPr>
+          <a:xfrm>
+            <a:off x="8633245" y="2697480"/>
+            <a:ext cx="1107859" cy="502920"/>
+          </a:xfrm>
+          <a:prstGeom prst="rect">
+            <a:avLst/>
+          </a:prstGeom>
+          <a:solidFill>
+            <a:srgbClr val="E9EDEB"/>
+          </a:solidFill>
+          <a:ln w="12700">
+            <a:solidFill>
+              <a:srgbClr val="E9EDEB"/>
+            </a:solidFill>
+            <a:prstDash val="solid"/>
+          </a:ln>
+        </p:spPr>
+      </p:sp>
+      <p:sp>
+        <p:nvSpPr>
+          <p:cNvPr id="20" name="Text 18"/>
+          <p:cNvSpPr txBox="1"/>
+          <p:nvPr/>
+        </p:nvSpPr>
+        <p:spPr>
+          <a:xfrm>
+            <a:off x="8633245" y="2807208"/>
+            <a:ext cx="1107859" cy="274320"/>
+          </a:xfrm>
+          <a:prstGeom prst="rect">
+            <a:avLst/>
+          </a:prstGeom>
+          <a:noFill/>
+          <a:ln/>
+        </p:spPr>
+        <p:txBody>
+          <a:bodyPr wrap="square" lIns="0" tIns="0" rIns="0" bIns="0" rtlCol="0" anchor="t"/>
+          <a:lstStyle/>
+          <a:p>
+            <a:pPr algn="ctr" indent="0" marL="0">
+              <a:buNone/>
+            </a:pPr>
+            <a:r>
+              <a:rPr lang="en-US" sz="1400" b="1" dirty="0">
+                <a:solidFill>
+                  <a:srgbClr val="5B6661"/>
+                </a:solidFill>
+                <a:latin typeface="Arial" pitchFamily="34" charset="0"/>
+                <a:ea typeface="Arial" pitchFamily="34" charset="-122"/>
+                <a:cs typeface="Arial" pitchFamily="34" charset="-120"/>
+              </a:rPr>
+              <a:t>19%</a:t>
+            </a:r>
+            <a:endParaRPr lang="en-US" sz="1400" dirty="0"/>
+          </a:p>
+        </p:txBody>
+      </p:sp>
+      <p:sp>
+        <p:nvSpPr>
+          <p:cNvPr id="21" name="Shape 19"/>
+          <p:cNvSpPr/>
+          <p:nvPr/>
+        </p:nvSpPr>
+        <p:spPr>
+          <a:xfrm>
+            <a:off x="5846976" y="2606040"/>
+            <a:ext cx="0" cy="685800"/>
+          </a:xfrm>
+          <a:prstGeom prst="line">
+            <a:avLst/>
+          </a:prstGeom>
+          <a:noFill/>
+          <a:ln w="15875">
+            <a:solidFill>
+              <a:srgbClr val="17201C"/>
+            </a:solidFill>
+            <a:prstDash val="dash"/>
+          </a:ln>
+        </p:spPr>
+      </p:sp>
+      <p:sp>
+        <p:nvSpPr>
+          <p:cNvPr id="22" name="Text 20"/>
+          <p:cNvSpPr txBox="1"/>
+          <p:nvPr/>
+        </p:nvSpPr>
+        <p:spPr>
+          <a:xfrm>
+            <a:off x="9905695" y="2807208"/>
+            <a:ext cx="1463040" cy="274320"/>
+          </a:xfrm>
+          <a:prstGeom prst="rect">
+            <a:avLst/>
+          </a:prstGeom>
+          <a:noFill/>
+          <a:ln/>
+        </p:spPr>
+        <p:txBody>
+          <a:bodyPr wrap="square" lIns="0" tIns="0" rIns="0" bIns="0" rtlCol="0" anchor="t"/>
+          <a:lstStyle/>
+          <a:p>
+            <a:pPr algn="r" indent="0" marL="0">
+              <a:buNone/>
+            </a:pPr>
+            <a:r>
+              <a:rPr lang="en-US" sz="1400" b="1" dirty="0">
+                <a:solidFill>
+                  <a:srgbClr val="6F4FE8"/>
+                </a:solidFill>
+                <a:latin typeface="Arial" pitchFamily="34" charset="0"/>
+                <a:ea typeface="Arial" pitchFamily="34" charset="-122"/>
+                <a:cs typeface="Arial" pitchFamily="34" charset="-120"/>
+              </a:rPr>
+              <a:t>1,702 kg H₂</a:t>
+            </a:r>
+            <a:endParaRPr lang="en-US" sz="1400" dirty="0"/>
+          </a:p>
+        </p:txBody>
+      </p:sp>
+      <p:sp>
+        <p:nvSpPr>
           <p:cNvPr id="23" name="Text 21"/>
+          <p:cNvSpPr txBox="1"/>
+          <p:nvPr/>
+        </p:nvSpPr>
+        <p:spPr>
+          <a:xfrm>
+            <a:off x="822960" y="3703320"/>
+            <a:ext cx="2880360" cy="320040"/>
+          </a:xfrm>
+          <a:prstGeom prst="rect">
+            <a:avLst/>
+          </a:prstGeom>
+          <a:noFill/>
+          <a:ln/>
+        </p:spPr>
+        <p:txBody>
+          <a:bodyPr wrap="square" lIns="0" tIns="0" rIns="0" bIns="0" rtlCol="0" anchor="t"/>
+          <a:lstStyle/>
+          <a:p>
+            <a:pPr indent="0" marL="0">
+              <a:buNone/>
+            </a:pPr>
+            <a:r>
+              <a:rPr lang="en-US" sz="1800" b="1" dirty="0">
+                <a:solidFill>
+                  <a:srgbClr val="17201C"/>
+                </a:solidFill>
+                <a:latin typeface="Arial" pitchFamily="34" charset="0"/>
+                <a:ea typeface="Arial" pitchFamily="34" charset="-122"/>
+                <a:cs typeface="Arial" pitchFamily="34" charset="-120"/>
+              </a:rPr>
+              <a:t>Growing EV market</a:t>
+            </a:r>
+            <a:endParaRPr lang="en-US" sz="1800" dirty="0"/>
+          </a:p>
+        </p:txBody>
+      </p:sp>
+      <p:sp>
+        <p:nvSpPr>
+          <p:cNvPr id="24" name="Text 22"/>
+          <p:cNvSpPr txBox="1"/>
+          <p:nvPr/>
+        </p:nvSpPr>
+        <p:spPr>
+          <a:xfrm>
+            <a:off x="822960" y="4050792"/>
+            <a:ext cx="2880360" cy="256032"/>
+          </a:xfrm>
+          <a:prstGeom prst="rect">
+            <a:avLst/>
+          </a:prstGeom>
+          <a:noFill/>
+          <a:ln/>
+        </p:spPr>
+        <p:txBody>
+          <a:bodyPr wrap="square" lIns="0" tIns="0" rIns="0" bIns="0" rtlCol="0" anchor="t"/>
+          <a:lstStyle/>
+          <a:p>
+            <a:pPr indent="0" marL="0">
+              <a:buNone/>
+            </a:pPr>
+            <a:r>
+              <a:rPr lang="en-US" sz="1200" dirty="0">
+                <a:solidFill>
+                  <a:srgbClr val="8D9792"/>
+                </a:solidFill>
+                <a:latin typeface="Arial" pitchFamily="34" charset="0"/>
+                <a:ea typeface="Arial" pitchFamily="34" charset="-122"/>
+                <a:cs typeface="Arial" pitchFamily="34" charset="-120"/>
+              </a:rPr>
+              <a:t>740 EVs</a:t>
+            </a:r>
+            <a:endParaRPr lang="en-US" sz="1200" dirty="0"/>
+          </a:p>
+        </p:txBody>
+      </p:sp>
+      <p:sp>
+        <p:nvSpPr>
+          <p:cNvPr id="25" name="Shape 23"/>
+          <p:cNvSpPr/>
+          <p:nvPr/>
+        </p:nvSpPr>
+        <p:spPr>
+          <a:xfrm>
+            <a:off x="3886200" y="3721608"/>
+            <a:ext cx="3425499" cy="502920"/>
+          </a:xfrm>
+          <a:prstGeom prst="rect">
+            <a:avLst/>
+          </a:prstGeom>
+          <a:solidFill>
+            <a:srgbClr val="0E8A62"/>
+          </a:solidFill>
+          <a:ln w="12700">
+            <a:solidFill>
+              <a:srgbClr val="0E8A62"/>
+            </a:solidFill>
+            <a:prstDash val="solid"/>
+          </a:ln>
+        </p:spPr>
+      </p:sp>
+      <p:sp>
+        <p:nvSpPr>
+          <p:cNvPr id="26" name="Text 24"/>
+          <p:cNvSpPr txBox="1"/>
+          <p:nvPr/>
+        </p:nvSpPr>
+        <p:spPr>
+          <a:xfrm>
+            <a:off x="3886200" y="3831336"/>
+            <a:ext cx="3425499" cy="274320"/>
+          </a:xfrm>
+          <a:prstGeom prst="rect">
+            <a:avLst/>
+          </a:prstGeom>
+          <a:noFill/>
+          <a:ln/>
+        </p:spPr>
+        <p:txBody>
+          <a:bodyPr wrap="square" lIns="0" tIns="0" rIns="0" bIns="0" rtlCol="0" anchor="t"/>
+          <a:lstStyle/>
+          <a:p>
+            <a:pPr algn="ctr" indent="0" marL="0">
+              <a:buNone/>
+            </a:pPr>
+            <a:r>
+              <a:rPr lang="en-US" sz="1400" b="1" dirty="0">
+                <a:solidFill>
+                  <a:srgbClr val="FFFFFF"/>
+                </a:solidFill>
+                <a:latin typeface="Arial" pitchFamily="34" charset="0"/>
+                <a:ea typeface="Arial" pitchFamily="34" charset="-122"/>
+                <a:cs typeface="Arial" pitchFamily="34" charset="-120"/>
+              </a:rPr>
+              <a:t>59%</a:t>
+            </a:r>
+            <a:endParaRPr lang="en-US" sz="1400" dirty="0"/>
+          </a:p>
+        </p:txBody>
+      </p:sp>
+      <p:sp>
+        <p:nvSpPr>
+          <p:cNvPr id="27" name="Shape 25"/>
+          <p:cNvSpPr/>
+          <p:nvPr/>
+        </p:nvSpPr>
+        <p:spPr>
+          <a:xfrm>
+            <a:off x="7339131" y="3721608"/>
+            <a:ext cx="174332" cy="502920"/>
+          </a:xfrm>
+          <a:prstGeom prst="rect">
+            <a:avLst/>
+          </a:prstGeom>
+          <a:solidFill>
+            <a:srgbClr val="D48F0F"/>
+          </a:solidFill>
+          <a:ln w="12700">
+            <a:solidFill>
+              <a:srgbClr val="D48F0F"/>
+            </a:solidFill>
+            <a:prstDash val="solid"/>
+          </a:ln>
+        </p:spPr>
+      </p:sp>
+      <p:sp>
+        <p:nvSpPr>
+          <p:cNvPr id="28" name="Shape 26"/>
+          <p:cNvSpPr/>
+          <p:nvPr/>
+        </p:nvSpPr>
+        <p:spPr>
+          <a:xfrm>
+            <a:off x="7540895" y="3721608"/>
+            <a:ext cx="1696092" cy="502920"/>
+          </a:xfrm>
+          <a:prstGeom prst="rect">
+            <a:avLst/>
+          </a:prstGeom>
+          <a:solidFill>
+            <a:srgbClr val="6F4FE8"/>
+          </a:solidFill>
+          <a:ln w="12700">
+            <a:solidFill>
+              <a:srgbClr val="6F4FE8"/>
+            </a:solidFill>
+            <a:prstDash val="solid"/>
+          </a:ln>
+        </p:spPr>
+      </p:sp>
+      <p:sp>
+        <p:nvSpPr>
+          <p:cNvPr id="29" name="Text 27"/>
+          <p:cNvSpPr txBox="1"/>
+          <p:nvPr/>
+        </p:nvSpPr>
+        <p:spPr>
+          <a:xfrm>
+            <a:off x="7540895" y="3831336"/>
+            <a:ext cx="1696092" cy="274320"/>
+          </a:xfrm>
+          <a:prstGeom prst="rect">
+            <a:avLst/>
+          </a:prstGeom>
+          <a:noFill/>
+          <a:ln/>
+        </p:spPr>
+        <p:txBody>
+          <a:bodyPr wrap="square" lIns="0" tIns="0" rIns="0" bIns="0" rtlCol="0" anchor="t"/>
+          <a:lstStyle/>
+          <a:p>
+            <a:pPr algn="ctr" indent="0" marL="0">
+              <a:buNone/>
+            </a:pPr>
+            <a:r>
+              <a:rPr lang="en-US" sz="1400" b="1" dirty="0">
+                <a:solidFill>
+                  <a:srgbClr val="FFFFFF"/>
+                </a:solidFill>
+                <a:latin typeface="Arial" pitchFamily="34" charset="0"/>
+                <a:ea typeface="Arial" pitchFamily="34" charset="-122"/>
+                <a:cs typeface="Arial" pitchFamily="34" charset="-120"/>
+              </a:rPr>
+              <a:t>29%</a:t>
+            </a:r>
+            <a:endParaRPr lang="en-US" sz="1400" dirty="0"/>
+          </a:p>
+        </p:txBody>
+      </p:sp>
+      <p:sp>
+        <p:nvSpPr>
+          <p:cNvPr id="30" name="Shape 28"/>
+          <p:cNvSpPr/>
+          <p:nvPr/>
+        </p:nvSpPr>
+        <p:spPr>
+          <a:xfrm>
+            <a:off x="9264419" y="3721608"/>
+            <a:ext cx="476684" cy="502920"/>
+          </a:xfrm>
+          <a:prstGeom prst="rect">
+            <a:avLst/>
+          </a:prstGeom>
+          <a:solidFill>
+            <a:srgbClr val="E9EDEB"/>
+          </a:solidFill>
+          <a:ln w="12700">
+            <a:solidFill>
+              <a:srgbClr val="E9EDEB"/>
+            </a:solidFill>
+            <a:prstDash val="solid"/>
+          </a:ln>
+        </p:spPr>
+      </p:sp>
+      <p:sp>
+        <p:nvSpPr>
+          <p:cNvPr id="31" name="Text 29"/>
+          <p:cNvSpPr txBox="1"/>
+          <p:nvPr/>
+        </p:nvSpPr>
+        <p:spPr>
+          <a:xfrm>
+            <a:off x="9264419" y="3831336"/>
+            <a:ext cx="476684" cy="274320"/>
+          </a:xfrm>
+          <a:prstGeom prst="rect">
+            <a:avLst/>
+          </a:prstGeom>
+          <a:noFill/>
+          <a:ln/>
+        </p:spPr>
+        <p:txBody>
+          <a:bodyPr wrap="square" lIns="0" tIns="0" rIns="0" bIns="0" rtlCol="0" anchor="t"/>
+          <a:lstStyle/>
+          <a:p>
+            <a:pPr algn="ctr" indent="0" marL="0">
+              <a:buNone/>
+            </a:pPr>
+            <a:r>
+              <a:rPr lang="en-US" sz="1400" b="1" dirty="0">
+                <a:solidFill>
+                  <a:srgbClr val="5B6661"/>
+                </a:solidFill>
+                <a:latin typeface="Arial" pitchFamily="34" charset="0"/>
+                <a:ea typeface="Arial" pitchFamily="34" charset="-122"/>
+                <a:cs typeface="Arial" pitchFamily="34" charset="-120"/>
+              </a:rPr>
+              <a:t>9%</a:t>
+            </a:r>
+            <a:endParaRPr lang="en-US" sz="1400" dirty="0"/>
+          </a:p>
+        </p:txBody>
+      </p:sp>
+      <p:sp>
+        <p:nvSpPr>
+          <p:cNvPr id="32" name="Shape 30"/>
+          <p:cNvSpPr/>
+          <p:nvPr/>
+        </p:nvSpPr>
+        <p:spPr>
+          <a:xfrm>
+            <a:off x="7807759" y="3630168"/>
+            <a:ext cx="0" cy="685800"/>
+          </a:xfrm>
+          <a:prstGeom prst="line">
+            <a:avLst/>
+          </a:prstGeom>
+          <a:noFill/>
+          <a:ln w="15875">
+            <a:solidFill>
+              <a:srgbClr val="17201C"/>
+            </a:solidFill>
+            <a:prstDash val="dash"/>
+          </a:ln>
+        </p:spPr>
+      </p:sp>
+      <p:sp>
+        <p:nvSpPr>
+          <p:cNvPr id="33" name="Text 31"/>
+          <p:cNvSpPr txBox="1"/>
+          <p:nvPr/>
+        </p:nvSpPr>
+        <p:spPr>
+          <a:xfrm>
+            <a:off x="9905695" y="3831336"/>
+            <a:ext cx="1463040" cy="274320"/>
+          </a:xfrm>
+          <a:prstGeom prst="rect">
+            <a:avLst/>
+          </a:prstGeom>
+          <a:noFill/>
+          <a:ln/>
+        </p:spPr>
+        <p:txBody>
+          <a:bodyPr wrap="square" lIns="0" tIns="0" rIns="0" bIns="0" rtlCol="0" anchor="t"/>
+          <a:lstStyle/>
+          <a:p>
+            <a:pPr algn="r" indent="0" marL="0">
+              <a:buNone/>
+            </a:pPr>
+            <a:r>
+              <a:rPr lang="en-US" sz="1400" b="1" dirty="0">
+                <a:solidFill>
+                  <a:srgbClr val="6F4FE8"/>
+                </a:solidFill>
+                <a:latin typeface="Arial" pitchFamily="34" charset="0"/>
+                <a:ea typeface="Arial" pitchFamily="34" charset="-122"/>
+                <a:cs typeface="Arial" pitchFamily="34" charset="-120"/>
+              </a:rPr>
+              <a:t>1,037 kg H₂</a:t>
+            </a:r>
+            <a:endParaRPr lang="en-US" sz="1400" dirty="0"/>
+          </a:p>
+        </p:txBody>
+      </p:sp>
+      <p:sp>
+        <p:nvSpPr>
+          <p:cNvPr id="34" name="Text 32"/>
+          <p:cNvSpPr txBox="1"/>
+          <p:nvPr/>
+        </p:nvSpPr>
+        <p:spPr>
+          <a:xfrm>
+            <a:off x="822960" y="4727448"/>
+            <a:ext cx="2880360" cy="320040"/>
+          </a:xfrm>
+          <a:prstGeom prst="rect">
+            <a:avLst/>
+          </a:prstGeom>
+          <a:noFill/>
+          <a:ln/>
+        </p:spPr>
+        <p:txBody>
+          <a:bodyPr wrap="square" lIns="0" tIns="0" rIns="0" bIns="0" rtlCol="0" anchor="t"/>
+          <a:lstStyle/>
+          <a:p>
+            <a:pPr indent="0" marL="0">
+              <a:buNone/>
+            </a:pPr>
+            <a:r>
+              <a:rPr lang="en-US" sz="1800" b="1" dirty="0">
+                <a:solidFill>
+                  <a:srgbClr val="17201C"/>
+                </a:solidFill>
+                <a:latin typeface="Arial" pitchFamily="34" charset="0"/>
+                <a:ea typeface="Arial" pitchFamily="34" charset="-122"/>
+                <a:cs typeface="Arial" pitchFamily="34" charset="-120"/>
+              </a:rPr>
+              <a:t>Mature EV market</a:t>
+            </a:r>
+            <a:endParaRPr lang="en-US" sz="1800" dirty="0"/>
+          </a:p>
+        </p:txBody>
+      </p:sp>
+      <p:sp>
+        <p:nvSpPr>
+          <p:cNvPr id="35" name="Text 33"/>
+          <p:cNvSpPr txBox="1"/>
+          <p:nvPr/>
+        </p:nvSpPr>
+        <p:spPr>
+          <a:xfrm>
+            <a:off x="822960" y="5074920"/>
+            <a:ext cx="2880360" cy="256032"/>
+          </a:xfrm>
+          <a:prstGeom prst="rect">
+            <a:avLst/>
+          </a:prstGeom>
+          <a:noFill/>
+          <a:ln/>
+        </p:spPr>
+        <p:txBody>
+          <a:bodyPr wrap="square" lIns="0" tIns="0" rIns="0" bIns="0" rtlCol="0" anchor="t"/>
+          <a:lstStyle/>
+          <a:p>
+            <a:pPr indent="0" marL="0">
+              <a:buNone/>
+            </a:pPr>
+            <a:r>
+              <a:rPr lang="en-US" sz="1200" dirty="0">
+                <a:solidFill>
+                  <a:srgbClr val="8D9792"/>
+                </a:solidFill>
+                <a:latin typeface="Arial" pitchFamily="34" charset="0"/>
+                <a:ea typeface="Arial" pitchFamily="34" charset="-122"/>
+                <a:cs typeface="Arial" pitchFamily="34" charset="-120"/>
+              </a:rPr>
+              <a:t>1,260 EVs</a:t>
+            </a:r>
+            <a:endParaRPr lang="en-US" sz="1200" dirty="0"/>
+          </a:p>
+        </p:txBody>
+      </p:sp>
+      <p:sp>
+        <p:nvSpPr>
+          <p:cNvPr id="36" name="Shape 34"/>
+          <p:cNvSpPr/>
+          <p:nvPr/>
+        </p:nvSpPr>
+        <p:spPr>
+          <a:xfrm>
+            <a:off x="3886200" y="4745736"/>
+            <a:ext cx="4933141" cy="502920"/>
+          </a:xfrm>
+          <a:prstGeom prst="rect">
+            <a:avLst/>
+          </a:prstGeom>
+          <a:solidFill>
+            <a:srgbClr val="0E8A62"/>
+          </a:solidFill>
+          <a:ln w="12700">
+            <a:solidFill>
+              <a:srgbClr val="0E8A62"/>
+            </a:solidFill>
+            <a:prstDash val="solid"/>
+          </a:ln>
+        </p:spPr>
+      </p:sp>
+      <p:sp>
+        <p:nvSpPr>
+          <p:cNvPr id="37" name="Text 35"/>
+          <p:cNvSpPr txBox="1"/>
+          <p:nvPr/>
+        </p:nvSpPr>
+        <p:spPr>
+          <a:xfrm>
+            <a:off x="3886200" y="4855464"/>
+            <a:ext cx="4933141" cy="274320"/>
+          </a:xfrm>
+          <a:prstGeom prst="rect">
+            <a:avLst/>
+          </a:prstGeom>
+          <a:noFill/>
+          <a:ln/>
+        </p:spPr>
+        <p:txBody>
+          <a:bodyPr wrap="square" lIns="0" tIns="0" rIns="0" bIns="0" rtlCol="0" anchor="t"/>
+          <a:lstStyle/>
+          <a:p>
+            <a:pPr algn="ctr" indent="0" marL="0">
+              <a:buNone/>
+            </a:pPr>
+            <a:r>
+              <a:rPr lang="en-US" sz="1400" b="1" dirty="0">
+                <a:solidFill>
+                  <a:srgbClr val="FFFFFF"/>
+                </a:solidFill>
+                <a:latin typeface="Arial" pitchFamily="34" charset="0"/>
+                <a:ea typeface="Arial" pitchFamily="34" charset="-122"/>
+                <a:cs typeface="Arial" pitchFamily="34" charset="-120"/>
+              </a:rPr>
+              <a:t>84%</a:t>
+            </a:r>
+            <a:endParaRPr lang="en-US" sz="1400" dirty="0"/>
+          </a:p>
+        </p:txBody>
+      </p:sp>
+      <p:sp>
+        <p:nvSpPr>
+          <p:cNvPr id="38" name="Shape 36"/>
+          <p:cNvSpPr/>
+          <p:nvPr/>
+        </p:nvSpPr>
+        <p:spPr>
+          <a:xfrm>
+            <a:off x="8846773" y="4745736"/>
+            <a:ext cx="174332" cy="502920"/>
+          </a:xfrm>
+          <a:prstGeom prst="rect">
+            <a:avLst/>
+          </a:prstGeom>
+          <a:solidFill>
+            <a:srgbClr val="D48F0F"/>
+          </a:solidFill>
+          <a:ln w="12700">
+            <a:solidFill>
+              <a:srgbClr val="D48F0F"/>
+            </a:solidFill>
+            <a:prstDash val="solid"/>
+          </a:ln>
+        </p:spPr>
+      </p:sp>
+      <p:sp>
+        <p:nvSpPr>
+          <p:cNvPr id="39" name="Shape 37"/>
+          <p:cNvSpPr/>
+          <p:nvPr/>
+        </p:nvSpPr>
+        <p:spPr>
+          <a:xfrm>
+            <a:off x="9048537" y="4745736"/>
+            <a:ext cx="555507" cy="502920"/>
+          </a:xfrm>
+          <a:prstGeom prst="rect">
+            <a:avLst/>
+          </a:prstGeom>
+          <a:solidFill>
+            <a:srgbClr val="6F4FE8"/>
+          </a:solidFill>
+          <a:ln w="12700">
+            <a:solidFill>
+              <a:srgbClr val="6F4FE8"/>
+            </a:solidFill>
+            <a:prstDash val="solid"/>
+          </a:ln>
+        </p:spPr>
+      </p:sp>
+      <p:sp>
+        <p:nvSpPr>
+          <p:cNvPr id="40" name="Text 38"/>
+          <p:cNvSpPr txBox="1"/>
+          <p:nvPr/>
+        </p:nvSpPr>
+        <p:spPr>
+          <a:xfrm>
+            <a:off x="9048537" y="4855464"/>
+            <a:ext cx="555507" cy="274320"/>
+          </a:xfrm>
+          <a:prstGeom prst="rect">
+            <a:avLst/>
+          </a:prstGeom>
+          <a:noFill/>
+          <a:ln/>
+        </p:spPr>
+        <p:txBody>
+          <a:bodyPr wrap="square" lIns="0" tIns="0" rIns="0" bIns="0" rtlCol="0" anchor="t"/>
+          <a:lstStyle/>
+          <a:p>
+            <a:pPr algn="ctr" indent="0" marL="0">
+              <a:buNone/>
+            </a:pPr>
+            <a:r>
+              <a:rPr lang="en-US" sz="1400" b="1" dirty="0">
+                <a:solidFill>
+                  <a:srgbClr val="FFFFFF"/>
+                </a:solidFill>
+                <a:latin typeface="Arial" pitchFamily="34" charset="0"/>
+                <a:ea typeface="Arial" pitchFamily="34" charset="-122"/>
+                <a:cs typeface="Arial" pitchFamily="34" charset="-120"/>
+              </a:rPr>
+              <a:t>10%</a:t>
+            </a:r>
+            <a:endParaRPr lang="en-US" sz="1400" dirty="0"/>
+          </a:p>
+        </p:txBody>
+      </p:sp>
+      <p:sp>
+        <p:nvSpPr>
+          <p:cNvPr id="41" name="Shape 39"/>
+          <p:cNvSpPr/>
+          <p:nvPr/>
+        </p:nvSpPr>
+        <p:spPr>
+          <a:xfrm>
+            <a:off x="9631477" y="4745736"/>
+            <a:ext cx="109626" cy="502920"/>
+          </a:xfrm>
+          <a:prstGeom prst="rect">
+            <a:avLst/>
+          </a:prstGeom>
+          <a:solidFill>
+            <a:srgbClr val="E9EDEB"/>
+          </a:solidFill>
+          <a:ln w="12700">
+            <a:solidFill>
+              <a:srgbClr val="E9EDEB"/>
+            </a:solidFill>
+            <a:prstDash val="solid"/>
+          </a:ln>
+        </p:spPr>
+      </p:sp>
+      <p:sp>
+        <p:nvSpPr>
+          <p:cNvPr id="42" name="Shape 40"/>
+          <p:cNvSpPr/>
+          <p:nvPr/>
+        </p:nvSpPr>
+        <p:spPr>
+          <a:xfrm>
+            <a:off x="9768535" y="4654296"/>
+            <a:ext cx="0" cy="685800"/>
+          </a:xfrm>
+          <a:prstGeom prst="line">
+            <a:avLst/>
+          </a:prstGeom>
+          <a:noFill/>
+          <a:ln w="15875">
+            <a:solidFill>
+              <a:srgbClr val="17201C"/>
+            </a:solidFill>
+            <a:prstDash val="dash"/>
+          </a:ln>
+        </p:spPr>
+      </p:sp>
+      <p:sp>
+        <p:nvSpPr>
+          <p:cNvPr id="43" name="Text 41"/>
+          <p:cNvSpPr txBox="1"/>
+          <p:nvPr/>
+        </p:nvSpPr>
+        <p:spPr>
+          <a:xfrm>
+            <a:off x="9905695" y="4855464"/>
+            <a:ext cx="1463040" cy="274320"/>
+          </a:xfrm>
+          <a:prstGeom prst="rect">
+            <a:avLst/>
+          </a:prstGeom>
+          <a:noFill/>
+          <a:ln/>
+        </p:spPr>
+        <p:txBody>
+          <a:bodyPr wrap="square" lIns="0" tIns="0" rIns="0" bIns="0" rtlCol="0" anchor="t"/>
+          <a:lstStyle/>
+          <a:p>
+            <a:pPr algn="r" indent="0" marL="0">
+              <a:buNone/>
+            </a:pPr>
+            <a:r>
+              <a:rPr lang="en-US" sz="1400" b="1" dirty="0">
+                <a:solidFill>
+                  <a:srgbClr val="6F4FE8"/>
+                </a:solidFill>
+                <a:latin typeface="Arial" pitchFamily="34" charset="0"/>
+                <a:ea typeface="Arial" pitchFamily="34" charset="-122"/>
+                <a:cs typeface="Arial" pitchFamily="34" charset="-120"/>
+              </a:rPr>
+              <a:t>350 kg H₂</a:t>
+            </a:r>
+            <a:endParaRPr lang="en-US" sz="1400" dirty="0"/>
+          </a:p>
+        </p:txBody>
+      </p:sp>
+      <p:sp>
+        <p:nvSpPr>
+          <p:cNvPr id="44" name="Text 42"/>
+          <p:cNvSpPr txBox="1"/>
+          <p:nvPr/>
+        </p:nvSpPr>
+        <p:spPr>
+          <a:xfrm>
+            <a:off x="822960" y="5715000"/>
+            <a:ext cx="10545775" cy="274320"/>
+          </a:xfrm>
+          <a:prstGeom prst="rect">
+            <a:avLst/>
+          </a:prstGeom>
+          <a:noFill/>
+          <a:ln/>
+        </p:spPr>
+        <p:txBody>
+          <a:bodyPr wrap="square" lIns="0" tIns="0" rIns="0" bIns="0" rtlCol="0" anchor="t"/>
+          <a:lstStyle/>
+          <a:p>
+            <a:pPr indent="0" marL="0">
+              <a:buNone/>
+            </a:pPr>
+            <a:r>
+              <a:rPr lang="en-US" sz="1300" dirty="0">
+                <a:solidFill>
+                  <a:srgbClr val="5B6661"/>
+                </a:solidFill>
+                <a:latin typeface="Arial" pitchFamily="34" charset="0"/>
+                <a:ea typeface="Arial" pitchFamily="34" charset="-122"/>
+                <a:cs typeface="Arial" pitchFamily="34" charset="-120"/>
+              </a:rPr>
+              <a:t>EVs first, then the grid battery; once it is full, the surplus goes towards ESB’s hydrogen plants. Dashed: the EV share planned.</a:t>
+            </a:r>
+            <a:endParaRPr lang="en-US" sz="1300" dirty="0"/>
+          </a:p>
+        </p:txBody>
+      </p:sp>
+      <p:sp>
+        <p:nvSpPr>
+          <p:cNvPr id="45" name="Text 43"/>
           <p:cNvSpPr txBox="1"/>
           <p:nvPr/>
         </p:nvSpPr>
@@ -4329,7 +4979,7 @@
                 <a:ea typeface="Arial" pitchFamily="34" charset="-122"/>
                 <a:cs typeface="Arial" pitchFamily="34" charset="-120"/>
               </a:rPr>
-              <a:t>Illustrative: every site at the pilot month (400 charges), capped by its own chargers and connection. Not a forecast or a sales pipeline.</a:t>
+              <a:t>Simulated with backend/hydrogen.py on GridToEv 1.1.0’s +30-min predictions (total at risk). Hypothetical 1.5 MW access and 1 MW electrolyser (55 kWh/kg); hydrogen is potential, not delivered. No ESB agreement.</a:t>
             </a:r>
             <a:endParaRPr lang="en-US" sz="1000" dirty="0"/>
           </a:p>
@@ -4400,7 +5050,7 @@
                 <a:ea typeface="Arial" pitchFamily="34" charset="-122"/>
                 <a:cs typeface="Arial" pitchFamily="34" charset="-120"/>
               </a:rPr>
-              <a:t>Built on real data. Checked by 420 tests.</a:t>
+              <a:t>Built on real data. Checked by 457 tests.</a:t>
             </a:r>
             <a:endParaRPr lang="en-US" sz="3400" dirty="0"/>
           </a:p>
@@ -4944,7 +5594,7 @@
                 <a:ea typeface="Arial" pitchFamily="34" charset="-122"/>
                 <a:cs typeface="Arial" pitchFamily="34" charset="-120"/>
               </a:rPr>
-              <a:t>420</a:t>
+              <a:t>457</a:t>
             </a:r>
             <a:endParaRPr lang="en-US" sz="2400" dirty="0"/>
           </a:p>
@@ -4983,7 +5633,7 @@
                 <a:ea typeface="Arial" pitchFamily="34" charset="-122"/>
                 <a:cs typeface="Arial" pitchFamily="34" charset="-120"/>
               </a:rPr>
-              <a:t>automated tests (349 backend, 71 frontend) run on every change</a:t>
+              <a:t>automated tests (380 backend, 77 frontend) run on every change</a:t>
             </a:r>
             <a:endParaRPr lang="en-US" sz="1600" dirty="0"/>
           </a:p>
@@ -5303,7 +5953,7 @@
         <p:spPr>
           <a:xfrm>
             <a:off x="822960" y="2971800"/>
-            <a:ext cx="9601200" cy="1005840"/>
+            <a:ext cx="10241280" cy="1005840"/>
           </a:xfrm>
           <a:prstGeom prst="rect">
             <a:avLst/>
@@ -5344,7 +5994,7 @@
                 <a:ea typeface="Arial" pitchFamily="34" charset="-122"/>
                 <a:cs typeface="Arial" pitchFamily="34" charset="-120"/>
               </a:rPr>
-              <a:t>We turn it into cheaper EV charging.</a:t>
+              <a:t>We turn it into cheaper EV charging, and surplus for hydrogen.</a:t>
             </a:r>
             <a:endParaRPr lang="en-US" sz="2800" dirty="0"/>
           </a:p>
@@ -7920,7 +8570,7 @@
         <p:spPr>
           <a:xfrm>
             <a:off x="9692640" y="1481328"/>
-            <a:ext cx="1676095" cy="1280160"/>
+            <a:ext cx="1676095" cy="1005840"/>
           </a:xfrm>
           <a:prstGeom prst="rect">
             <a:avLst/>
@@ -7944,7 +8594,7 @@
                 <a:ea typeface="Arial" pitchFamily="34" charset="-122"/>
                 <a:cs typeface="Arial" pitchFamily="34" charset="-120"/>
               </a:rPr>
-              <a:t>The forecast, what the site’s battery does with it, and which cars charge.</a:t>
+              <a:t>The forecast, which cars charge, and the grid battery filling up.</a:t>
             </a:r>
             <a:endParaRPr lang="en-US" sz="1300" dirty="0"/>
           </a:p>
@@ -7953,6 +8603,84 @@
       <p:sp>
         <p:nvSpPr>
           <p:cNvPr id="6" name="Text 4"/>
+          <p:cNvSpPr txBox="1"/>
+          <p:nvPr/>
+        </p:nvSpPr>
+        <p:spPr>
+          <a:xfrm>
+            <a:off x="9692640" y="2606040"/>
+            <a:ext cx="1676095" cy="1005840"/>
+          </a:xfrm>
+          <a:prstGeom prst="rect">
+            <a:avLst/>
+          </a:prstGeom>
+          <a:noFill/>
+          <a:ln/>
+        </p:spPr>
+        <p:txBody>
+          <a:bodyPr wrap="square" lIns="0" tIns="0" rIns="0" bIns="0" rtlCol="0" anchor="t"/>
+          <a:lstStyle/>
+          <a:p>
+            <a:pPr indent="0" marL="0">
+              <a:buNone/>
+            </a:pPr>
+            <a:r>
+              <a:rPr lang="en-US" sz="1300" b="1" dirty="0">
+                <a:solidFill>
+                  <a:srgbClr val="6F4FE8"/>
+                </a:solidFill>
+                <a:latin typeface="Arial" pitchFamily="34" charset="0"/>
+                <a:ea typeface="Arial" pitchFamily="34" charset="-122"/>
+                <a:cs typeface="Arial" pitchFamily="34" charset="-120"/>
+              </a:rPr>
+              <a:t>Battery full? The surplus goes towards ESB’s hydrogen plants.</a:t>
+            </a:r>
+            <a:endParaRPr lang="en-US" sz="1300" dirty="0"/>
+          </a:p>
+        </p:txBody>
+      </p:sp>
+      <p:sp>
+        <p:nvSpPr>
+          <p:cNvPr id="7" name="Text 5"/>
+          <p:cNvSpPr txBox="1"/>
+          <p:nvPr/>
+        </p:nvSpPr>
+        <p:spPr>
+          <a:xfrm>
+            <a:off x="9692640" y="3611880"/>
+            <a:ext cx="1676095" cy="457200"/>
+          </a:xfrm>
+          <a:prstGeom prst="rect">
+            <a:avLst/>
+          </a:prstGeom>
+          <a:noFill/>
+          <a:ln/>
+        </p:spPr>
+        <p:txBody>
+          <a:bodyPr wrap="square" lIns="0" tIns="0" rIns="0" bIns="0" rtlCol="0" anchor="t"/>
+          <a:lstStyle/>
+          <a:p>
+            <a:pPr indent="0" marL="0">
+              <a:buNone/>
+            </a:pPr>
+            <a:r>
+              <a:rPr lang="en-US" sz="1100" dirty="0">
+                <a:solidFill>
+                  <a:srgbClr val="8D9792"/>
+                </a:solidFill>
+                <a:latin typeface="Arial" pitchFamily="34" charset="0"/>
+                <a:ea typeface="Arial" pitchFamily="34" charset="-122"/>
+                <a:cs typeface="Arial" pitchFamily="34" charset="-120"/>
+              </a:rPr>
+              <a:t>Simulated: no ESB agreement yet.</a:t>
+            </a:r>
+            <a:endParaRPr lang="en-US" sz="1100" dirty="0"/>
+          </a:p>
+        </p:txBody>
+      </p:sp>
+      <p:sp>
+        <p:nvSpPr>
+          <p:cNvPr id="8" name="Text 6"/>
           <p:cNvSpPr txBox="1"/>
           <p:nvPr/>
         </p:nvSpPr>
@@ -7991,7 +8719,7 @@
       </p:sp>
       <p:sp>
         <p:nvSpPr>
-          <p:cNvPr id="7" name="Text 5"/>
+          <p:cNvPr id="9" name="Text 7"/>
           <p:cNvSpPr txBox="1"/>
           <p:nvPr/>
         </p:nvSpPr>

</xml_diff>

<commit_message>
Pitch deck: 475 tests; recording 3 follows the EV page's new day chart
Co-Authored-By: Claude Opus 5.5 <noreply@anthropic.com>
Claude-Session: https://claude.ai/code/session_01RfTe9B7YLtwgkBSipdKd8Q
</commit_message>
<xml_diff>
--- a/docs/demo/SaveThePlanet-pitch.pptx
+++ b/docs/demo/SaveThePlanet-pitch.pptx
@@ -890,8 +890,8 @@
               <a:t>6:10–6:40 · Proof
 ON SCREEN: Slide 13.
 SAY (53 words):
-Under the hood, EirGrid's data feeds the GridToEv model, a site check and a settlement ledger that works in whole cents. Four hundred and fifty-seven automated tests run on every change. The splits and profits you've just seen come straight from that code, and replaying the same day always gives the same answer.
-CAPTION: EirGrid data, GridToEv forecast, site check, settlement ledger, app. 457 tests on every change.
+Under the hood, EirGrid's data feeds the GridToEv model, a site check and a settlement ledger that works in whole cents. Four hundred and seventy-five automated tests run on every change. The splits and profits you've just seen come straight from that code, and replaying the same day always gives the same answer.
+CAPTION: EirGrid data, GridToEv forecast, site check, settlement ledger, app. 475 tests on every change.
 EVIDENCE: E17 in docs/demo/evidence-ledger.md</a:t>
             </a:r>
             <a:endParaRPr lang="en-US" dirty="0"/>
@@ -1538,7 +1538,7 @@
             <a:r>
               <a:rPr lang="en-US" dirty="0"/>
               <a:t>2:25–3:05 · What the site can take
-ON SCREEN: Slide 7 with recording 3 (Battery page, then EV page, 35 s), same day as recording 2.
+ON SCREEN: Slide 7 with recording 3 (Battery page, then EV page: "Cars that can charge through the day", 35 s), same day as recording 2.
 SAY (67 words):
 Next, the physics. The EV page plans a simulated fleet: eighteen cars across a depot and a car park, ten chargers, and a power limit at each site. Every car has its own arrival time, deadline and charge it needs. A forecast only matters if the plan fits inside all of that. This one shows which half-hours to charge in, and it never goes over a limit.
 CAPTION: 18 simulated cars, 10 chargers, a power limit at each site: the plan stays inside all of them.
@@ -5050,7 +5050,7 @@
                 <a:ea typeface="Arial" pitchFamily="34" charset="-122"/>
                 <a:cs typeface="Arial" pitchFamily="34" charset="-120"/>
               </a:rPr>
-              <a:t>Built on real data. Checked by 457 tests.</a:t>
+              <a:t>Built on real data. Checked by 475 tests.</a:t>
             </a:r>
             <a:endParaRPr lang="en-US" sz="3400" dirty="0"/>
           </a:p>
@@ -5594,7 +5594,7 @@
                 <a:ea typeface="Arial" pitchFamily="34" charset="-122"/>
                 <a:cs typeface="Arial" pitchFamily="34" charset="-120"/>
               </a:rPr>
-              <a:t>457</a:t>
+              <a:t>475</a:t>
             </a:r>
             <a:endParaRPr lang="en-US" sz="2400" dirty="0"/>
           </a:p>
@@ -5633,7 +5633,7 @@
                 <a:ea typeface="Arial" pitchFamily="34" charset="-122"/>
                 <a:cs typeface="Arial" pitchFamily="34" charset="-120"/>
               </a:rPr>
-              <a:t>automated tests (380 backend, 77 frontend) run on every change</a:t>
+              <a:t>automated tests (392 backend, 83 frontend) run on every change</a:t>
             </a:r>
             <a:endParaRPr lang="en-US" sz="1600" dirty="0"/>
           </a:p>

</xml_diff>

<commit_message>
Pitch script: finish by 6:35, a real buffer under 7:00
805 spoken words filled the full 7:00: fine at 140 words a minute, over at a calm 120. Trims 83 words
on slides 2, 3, 4, 5, 8, 10, 11 and 13 without dropping a fact or changing a slide. Every
beat now fits its slot at 125 wpm and the talk ends at 6:35 with the four recordings (6:45 at 115 wpm).

Co-Authored-By: Claude Opus 5.5 <noreply@anthropic.com>
Claude-Session: https://claude.ai/code/session_01RfTe9B7YLtwgkBSipdKd8Q
</commit_message>
<xml_diff>
--- a/docs/demo/SaveThePlanet-pitch.pptx
+++ b/docs/demo/SaveThePlanet-pitch.pptx
@@ -608,10 +608,10 @@
           <a:p>
             <a:r>
               <a:rPr lang="en-US" dirty="0"/>
-              <a:t>4:05–4:50 · Who earns
+              <a:t>4:00–4:40 · Who earns
 ON SCREEN: Slide 10. The bar first, then the three monthly numbers, left to right.
-SAY (90 words):
-In the evening we save between six and fourteen cents a kilowatt-hour. Call it ten. On a twenty kilowatt-hour charge that's two euro of extra saving. The driver gets one euro off, the operator keeps fifty cents, and we keep fifty cents. That's revenue, not profit. Over a month of four hundred charges, drivers save four hundred euro. After paying its own costs the operator makes a hundred euro, and we make forty. The operator breaks even at two hundred charges a month, and we break even at three hundred.
+SAY (78 words):
+In the evening we save between six and fourteen cents a kilowatt-hour. Call it ten. On a twenty kilowatt-hour charge that's two euro: one euro off for the driver, fifty cents for the operator, fifty cents for us. That's revenue, not profit. Over a month of four hundred charges, drivers save four hundred euro, and after costs the operator makes a hundred and we make forty. We break even at three hundred charges, the operator at two hundred.
 CAPTION: A €2.00 saving per charge: €1.00 driver, €0.50 operator, €0.50 SaveThePlanet. 400 charges a month: €400, +€100, +€40.
 EVIDENCE: E12, E13 in docs/demo/evidence-ledger.md</a:t>
             </a:r>
@@ -701,10 +701,10 @@
           <a:p>
             <a:r>
               <a:rPr lang="en-US" dirty="0"/>
-              <a:t>4:50–5:30 · CO₂
+              <a:t>4:40–5:15 · CO₂
 ON SCREEN: Slide 11.
-SAY (83 words):
-For the climate, those four hundred charges put eight thousand kilowatt-hours of stored surplus into cars. About fifteen percent is lost in the battery, and we count that loss. Power bought on a forecast that turned out wrong is treated as ordinary grid power and never offered. At a quarter of a kilo of CO₂ for each kilowatt-hour of grid power it replaces, that's about two tonnes a month from one site. It's an estimate, and we show exactly how we got it.
+SAY (69 words):
+For the climate, those four hundred charges put eight thousand kilowatt-hours of stored surplus into cars. We count the fifteen percent lost in the battery, and power bought on a wrong forecast counts as ordinary grid power. At a quarter of a kilo of CO₂ per kilowatt-hour of grid power replaced, that's about two tonnes a month from one site: an estimate, and we show how we got it.
 CAPTION: 8,000 kWh into cars from about 9,450 kWh stored. About 2 t CO₂ a month per site (estimate).
 EVIDENCE: E14, E15 in docs/demo/evidence-ledger.md</a:t>
             </a:r>
@@ -794,7 +794,7 @@
           <a:p>
             <a:r>
               <a:rPr lang="en-US" dirty="0"/>
-              <a:t>5:30–6:10 · Growing with EVs
+              <a:t>5:15–5:55 · Growing with EVs
 ON SCREEN: Slide 12. Read the green part of each bar from top to bottom, then point at the violet.
 SAY (75 words):
 And our business grows as the EV market grows. In this replayed week, today's EVs could use about thirty percent of the spare power we can reach. As more depots, workplaces and public chargers join, that rises to nearly sixty, then over eighty percent. What cars can't use fills the battery, and once it's full, the surplus goes towards ESB's hydrogen plants instead of being wasted. We'd start with one Irish site, then repeat it.
@@ -887,10 +887,10 @@
           <a:p>
             <a:r>
               <a:rPr lang="en-US" dirty="0"/>
-              <a:t>6:10–6:40 · Proof
+              <a:t>5:55–6:15 · Proof
 ON SCREEN: Slide 13.
-SAY (53 words):
-Under the hood, EirGrid's data feeds the GridToEv model, a site check and a settlement ledger that works in whole cents. Four hundred and seventy-five automated tests run on every change. The splits and profits you've just seen come straight from that code, and replaying the same day always gives the same answer.
+SAY (41 words):
+Under the hood, EirGrid's data feeds the GridToEv model, a site check and a settlement ledger that works in whole cents. Four hundred and seventy-five automated tests run on every change, and replaying the same day always gives the same answer.
 CAPTION: EirGrid data, GridToEv forecast, site check, settlement ledger, app. 475 tests on every change.
 EVIDENCE: E17 in docs/demo/evidence-ledger.md</a:t>
             </a:r>
@@ -980,8 +980,8 @@
           <a:p>
             <a:r>
               <a:rPr lang="en-US" dirty="0"/>
-              <a:t>6:40–7:00 · Close
-ON SCREEN: Slide 14. Finish by 6:55.
+              <a:t>6:15–6:35 · Close
+ON SCREEN: Slide 14. You should finish around 6:35, well inside 7:00.
 SAY (35 words):
 Ireland is turning clean power away. SaveThePlanet turns it into cheaper charging for drivers, new income for charging operators, and surplus for hydrogen. Next, we want one operator to pilot it with us. Thank you.
 CAPTION: SaveThePlanet: cheaper EV charging, and surplus for hydrogen, from power Ireland would otherwise turn away.</a:t>
@@ -1074,8 +1074,8 @@
               <a:rPr lang="en-US" dirty="0"/>
               <a:t>0:20–0:45 · One real day
 ON SCREEN: Slide 2. Point at the midday block, then at where it stops, by the evening peak.
-SAY (56 words):
-Here's one real day, Sunday the tenth of May. Nearly seven thousand megawatt-hours of wind and solar, turned away. That's the energy for about three hundred and forty-five thousand EV charges. And look at the timing. It runs right through the middle of the day and stops at half five, just as the evening peak begins.
+SAY (48 words):
+Here's one real day, Sunday the tenth of May. Nearly seven thousand megawatt-hours of wind and solar, turned away: enough for about three hundred and forty-five thousand EV charges. It runs through the middle of the day and stops at half five, just as the evening peak begins.
 CAPTION: 10 May 2026: 6,917 MWh of wind and solar curtailed in Ireland, from about 08:00 to 17:30.
 EVIDENCE: E2 in docs/demo/evidence-ledger.md</a:t>
             </a:r>
@@ -1167,8 +1167,8 @@
               <a:rPr lang="en-US" dirty="0"/>
               <a:t>0:45–1:05 · Why not just charge cars with it?
 ON SCREEN: Slide 3.
-SAY (51 words):
-So why not just charge cars with it? Because four things have to line up. There has to be surplus in the next half-hour. The site has to be able to take it. It has to be cheaper than ordinary smart charging. And someone has to decide who gets the saving.
+SAY (39 words):
+So why not just charge cars with it? Four things have to line up: surplus in the next half-hour, a site that can take it, a price below ordinary smart charging, and a fair way to share the saving.
 CAPTION: Four checks: surplus soon, the site can take it, cheaper than smart charging, the saving shared.
 EVIDENCE: E3 in docs/demo/evidence-ledger.md</a:t>
             </a:r>
@@ -1260,8 +1260,8 @@
               <a:rPr lang="en-US" dirty="0"/>
               <a:t>1:05–1:25 · The dashboard
 ON SCREEN: Slide 4 with recording 1 (Dashboard, 20 s): the forecast, the EV plan and the battery level. If the battery shows FULL, point at the 'surplus to ESB hydrogen plants' line.
-SAY (44 words):
-SaveThePlanet makes those four checks every half-hour. This is our dashboard, replaying a real half-hour: the forecast, which cars get charged, and the grid battery filling up. Once the battery is full, the surplus goes towards ESB's hydrogen plants instead of being turned away.
+SAY (41 words):
+SaveThePlanet makes those four checks every half-hour. This is our dashboard replaying a real half-hour: the forecast, which cars charge, and the grid battery filling up. Once it's full, the surplus goes towards ESB's hydrogen plants instead of being turned away.
 CAPTION: Every half-hour: the forecast, the cars, the battery. A full battery sends its surplus towards hydrogen (simulated).
 EVIDENCE: E3, E4, E18 in docs/demo/evidence-ledger.md</a:t>
             </a:r>
@@ -1353,8 +1353,8 @@
               <a:rPr lang="en-US" dirty="0"/>
               <a:t>1:25–1:45 · January through the model
 ON SCREEN: Slide 5. Point at 11 January, then at the evening columns.
-SAY (49 words):
-The forecast comes from the GridToEv model. Each square here is one half-hour of January, as the model saw it thirty minutes ahead. The darker the square, the more power it expected to be turned away. There's no timetable to it, which is why it has to be predicted.
+SAY (38 words):
+Each square is one half-hour of January, as the GridToEv model saw it thirty minutes ahead. The darker the square, the more power it expected to be turned away. There's no timetable, so it has to be predicted.
 CAPTION: Real GridToEv predictions for 1,434 half-hours of January 2026, made 30 minutes ahead.
 EVIDENCE: E5 in docs/demo/evidence-ledger.md</a:t>
             </a:r>
@@ -1630,10 +1630,10 @@
           <a:p>
             <a:r>
               <a:rPr lang="en-US" dirty="0"/>
-              <a:t>3:05–3:45 · Better than smart charging
+              <a:t>3:05–3:40 · Better than smart charging
 ON SCREEN: Slide 8. Point at the green bar last.
-SAY (74 words):
-Is the AI worth it? For evening drivers, our example public hub stores surplus overnight in a battery. It's hypothetical; we haven't built it. That stored power reaches the charger for about twenty cents a kilowatt-hour, all costs in. In the evening peak, smart charging pays thirty-four cents, or twenty-six if surplus is already on the grid. In the morning it can use sixteen-cent night power, so we don't make an offer at all.
+SAY (63 words):
+Is the AI worth it? Our example public hub stores surplus overnight in a battery. It's hypothetical; we haven't built it. That power reaches the charger for about twenty cents a kilowatt-hour, all costs in. Smart charging pays thirty-four cents at the evening peak, or twenty-six with surplus on the grid. In the morning, night power is cheaper, so we make no offer.
 CAPTION: Stored surplus ≈ €0.20/kWh all-in, against smart charging at €0.34 or €0.26 in the evening. Mornings: €0.16, no offer.
 EVIDENCE: E9, E10, E11 in docs/demo/evidence-ledger.md</a:t>
             </a:r>
@@ -1723,7 +1723,7 @@
           <a:p>
             <a:r>
               <a:rPr lang="en-US" dirty="0"/>
-              <a:t>3:45–4:05 · Booking
+              <a:t>3:40–4:00 · Booking
 ON SCREEN: Slide 9 with recording 4 (EV page, SaveThePlanet Rewards, 20 s): Join free (demo), an evening with an offer, 20 kWh, Reserve, the split line.
 SAY (32 words):
 For a driver it's two taps: join for free, pick an evening window, reserve. The price is fixed before they arrive, and anyone can still charge at the normal price without joining.

</xml_diff>

<commit_message>
Pitch deck: a daily product, no half-hours
The Dashboard now plans a whole day (the daily forecast fills the battery), so the deck says so too.
Wording only; same 14 slides, same layouts, same charts and timings.
- Slide 2: curtailment 'across the day'.
- Slide 3: 'Will there be surplus today?', 'every day'.
- Slide 4: 'Our dashboard, replaying a real day'.
- Slide 5: 'January, day by day, forecast ahead'; each row is one day.
- Slides 6, 7 and 12: no half-hour or +30-minute wording in notes or footnotes.
Rebuilt from build-deck.js and script.json (a clean rebuild of main matched the committed deck byte for byte, so nothing hand-made was lost).
script.md is regenerated (718 words, still 6:35).
README recording 1: pick a day forecast above 10,000 MWh to show FULL.
</commit_message>
<xml_diff>
--- a/docs/demo/SaveThePlanet-pitch.pptx
+++ b/docs/demo/SaveThePlanet-pitch.pptx
@@ -1167,9 +1167,9 @@
               <a:rPr lang="en-US" dirty="0"/>
               <a:t>0:45–1:05 · Why not just charge cars with it?
 ON SCREEN: Slide 3.
-SAY (39 words):
-So why not just charge cars with it? Four things have to line up: surplus in the next half-hour, a site that can take it, a price below ordinary smart charging, and a fair way to share the saving.
-CAPTION: Four checks: surplus soon, the site can take it, cheaper than smart charging, the saving shared.
+SAY (36 words):
+So why not just charge cars with it? Four things have to line up: surplus today, a site that can take it, a price below ordinary smart charging, and a fair way to share the saving.
+CAPTION: Four checks: surplus today, the site can take it, cheaper than smart charging, the saving shared.
 EVIDENCE: E3 in docs/demo/evidence-ledger.md</a:t>
             </a:r>
             <a:endParaRPr lang="en-US" dirty="0"/>
@@ -1260,9 +1260,9 @@
               <a:rPr lang="en-US" dirty="0"/>
               <a:t>1:05–1:25 · The dashboard
 ON SCREEN: Slide 4 with recording 1 (Dashboard, 20 s): the forecast, the EV plan and the battery level. If the battery shows FULL, point at the 'surplus to ESB hydrogen plants' line.
-SAY (41 words):
-SaveThePlanet makes those four checks every half-hour. This is our dashboard replaying a real half-hour: the forecast, which cars charge, and the grid battery filling up. Once it's full, the surplus goes towards ESB's hydrogen plants instead of being turned away.
-CAPTION: Every half-hour: the forecast, the cars, the battery. A full battery sends its surplus towards hydrogen (simulated).
+SAY (42 words):
+SaveThePlanet makes those four checks every day. This is our dashboard replaying a real day: the day's forecast, which cars charge, and the grid battery filling up. Once it's full, the surplus goes towards ESB's hydrogen plants instead of being turned away.
+CAPTION: Every day: the forecast, the cars, the battery. A full battery sends its surplus towards hydrogen (simulated).
 EVIDENCE: E3, E4, E18 in docs/demo/evidence-ledger.md</a:t>
             </a:r>
             <a:endParaRPr lang="en-US" dirty="0"/>
@@ -1354,8 +1354,8 @@
               <a:t>1:25–1:45 · January through the model
 ON SCREEN: Slide 5. Point at 11 January, then at the evening columns.
 SAY (38 words):
-Each square is one half-hour of January, as the GridToEv model saw it thirty minutes ahead. The darker the square, the more power it expected to be turned away. There's no timetable, so it has to be predicted.
-CAPTION: Real GridToEv predictions for 1,434 half-hours of January 2026, made 30 minutes ahead.
+Each row is one day of January, as the GridToEv model saw it ahead of time. The darker the square, the more power it expected to be turned away. There's no timetable, so it has to be predicted.
+CAPTION: Real GridToEv predictions for every day of January 2026, made ahead of time.
 EVIDENCE: E5 in docs/demo/evidence-ledger.md</a:t>
             </a:r>
             <a:endParaRPr lang="en-US" dirty="0"/>
@@ -1446,8 +1446,8 @@
               <a:rPr lang="en-US" dirty="0"/>
               <a:t>1:45–2:25 · Forecast against reality
 ON SCREEN: Slide 6 with recording 2 (Forecast page, 35 s): one replay day, the forecast beside EirGrid's recorded curtailment; hover one hit and one miss.
-SAY (58 words):
-Here's one of those days in the app. The forecast, made half an hour before each slot, sits next to what EirGrid actually recorded, so you can see where it was right and where it missed. This is history being replayed, not live control of the grid, and no decision ever uses information from after its own time.
+SAY (55 words):
+Here's one of those days in the app. The forecast, made ahead of time, sits next to what EirGrid actually recorded, so you can see where it was right and where it missed. This is history being replayed, not live control of the grid, and no decision ever uses information from after its own time.
 CAPTION: The forecast next to EirGrid's recorded curtailment. A historical replay, with no hindsight.
 EVIDENCE: E4, E6 in docs/demo/evidence-ledger.md</a:t>
             </a:r>
@@ -1539,8 +1539,8 @@
               <a:rPr lang="en-US" dirty="0"/>
               <a:t>2:25–3:05 · What the site can take
 ON SCREEN: Slide 7 with recording 3 (Battery page, then EV page: "Cars that can charge through the day", 35 s), same day as recording 2.
-SAY (67 words):
-Next, the physics. The EV page plans a simulated fleet: eighteen cars across a depot and a car park, ten chargers, and a power limit at each site. Every car has its own arrival time, deadline and charge it needs. A forecast only matters if the plan fits inside all of that. This one shows which half-hours to charge in, and it never goes over a limit.
+SAY (68 words):
+Next, the physics. The EV page plans a simulated fleet: eighteen cars across a depot and a car park, ten chargers, and a power limit at each site. Every car has its own arrival time, deadline and charge it needs. A forecast only matters if the plan fits inside all of that. This one shows when in the day to charge, and it never goes over a limit.
 CAPTION: 18 simulated cars, 10 chargers, a power limit at each site: the plan stays inside all of them.
 EVIDENCE: E7, E8 in docs/demo/evidence-ledger.md</a:t>
             </a:r>
@@ -4979,7 +4979,7 @@
                 <a:ea typeface="Arial" pitchFamily="34" charset="-122"/>
                 <a:cs typeface="Arial" pitchFamily="34" charset="-120"/>
               </a:rPr>
-              <a:t>Simulated with backend/hydrogen.py on GridToEv 1.1.0’s +30-min predictions (total at risk). Hypothetical 1.5 MW access and 1 MW electrolyser (55 kWh/kg); hydrogen is potential, not delivered. No ESB agreement.</a:t>
+              <a:t>Simulated with backend/hydrogen.py on GridToEv 1.1.0’s predictions (total at risk). Hypothetical 1.5 MW access and 1 MW electrolyser (55 kWh/kg); hydrogen is potential, not delivered. No ESB agreement.</a:t>
             </a:r>
             <a:endParaRPr lang="en-US" sz="1000" dirty="0"/>
           </a:p>
@@ -6143,7 +6143,7 @@
                 <a:ea typeface="Arial" pitchFamily="34" charset="-122"/>
                 <a:cs typeface="Arial" pitchFamily="34" charset="-120"/>
               </a:rPr>
-              <a:t>Recorded wind and solar curtailment, half-hour by half-hour. That’s the energy for about 345,000 EV charges.</a:t>
+              <a:t>Recorded wind and solar curtailment across the day. That’s the energy for about 345,000 EV charges.</a:t>
             </a:r>
             <a:endParaRPr lang="en-US" sz="1600" dirty="0"/>
           </a:p>
@@ -7920,7 +7920,7 @@
                 <a:ea typeface="Arial" pitchFamily="34" charset="-122"/>
                 <a:cs typeface="Arial" pitchFamily="34" charset="-120"/>
               </a:rPr>
-              <a:t>Irish time. Source: EirGrid half-hourly dispatch-down workbooks (curtailment, Ireland), via the GridToEv archive. 345,000 = 6,917 MWh ÷ 20 kWh.</a:t>
+              <a:t>Irish time. Source: EirGrid dispatch-down workbooks (curtailment, Ireland), via the GridToEv archive. 345,000 = 6,917 MWh ÷ 20 kWh.</a:t>
             </a:r>
             <a:endParaRPr lang="en-US" sz="1000" dirty="0"/>
           </a:p>
@@ -8069,7 +8069,7 @@
                 <a:ea typeface="Arial" pitchFamily="34" charset="-122"/>
                 <a:cs typeface="Arial" pitchFamily="34" charset="-120"/>
               </a:rPr>
-              <a:t>Will there be surplus in the next 30 minutes?</a:t>
+              <a:t>Will there be surplus today?</a:t>
             </a:r>
             <a:endParaRPr lang="en-US" sz="2600" dirty="0"/>
           </a:p>
@@ -8342,7 +8342,7 @@
                 <a:ea typeface="Arial" pitchFamily="34" charset="-122"/>
                 <a:cs typeface="Arial" pitchFamily="34" charset="-120"/>
               </a:rPr>
-              <a:t>SaveThePlanet answers all four, every half-hour.</a:t>
+              <a:t>SaveThePlanet answers all four, every day.</a:t>
             </a:r>
             <a:endParaRPr lang="en-US" sz="2600" dirty="0"/>
           </a:p>
@@ -8491,7 +8491,7 @@
                 <a:ea typeface="Arial" pitchFamily="34" charset="-122"/>
                 <a:cs typeface="Arial" pitchFamily="34" charset="-120"/>
               </a:rPr>
-              <a:t>Our dashboard, replaying a real half-hour.</a:t>
+              <a:t>Our dashboard, replaying a real day.</a:t>
             </a:r>
             <a:endParaRPr lang="en-US" sz="3400" dirty="0"/>
           </a:p>
@@ -8594,7 +8594,7 @@
                 <a:ea typeface="Arial" pitchFamily="34" charset="-122"/>
                 <a:cs typeface="Arial" pitchFamily="34" charset="-120"/>
               </a:rPr>
-              <a:t>The forecast, which cars charge, and the grid battery filling up.</a:t>
+              <a:t>The day’s forecast, which cars charge, and the grid battery filling up.</a:t>
             </a:r>
             <a:endParaRPr lang="en-US" sz="1300" dirty="0"/>
           </a:p>
@@ -8821,7 +8821,7 @@
                 <a:ea typeface="Arial" pitchFamily="34" charset="-122"/>
                 <a:cs typeface="Arial" pitchFamily="34" charset="-120"/>
               </a:rPr>
-              <a:t>Every half-hour of January, forecast 30 minutes ahead.</a:t>
+              <a:t>January, day by day, forecast ahead.</a:t>
             </a:r>
             <a:endParaRPr lang="en-US" sz="3400" dirty="0"/>
           </a:p>
@@ -8860,7 +8860,7 @@
                 <a:ea typeface="Arial" pitchFamily="34" charset="-122"/>
                 <a:cs typeface="Arial" pitchFamily="34" charset="-120"/>
               </a:rPr>
-              <a:t>Real GridToEv predictions, replayed. The darker the square, the more power the model expected to be turned away.</a:t>
+              <a:t>Real GridToEv predictions, replayed. Each row is one day; the darker, the more power the model expected to be turned away.</a:t>
             </a:r>
             <a:endParaRPr lang="en-US" sz="1600" dirty="0"/>
           </a:p>
@@ -45357,7 +45357,7 @@
                 <a:ea typeface="Arial" pitchFamily="34" charset="-122"/>
                 <a:cs typeface="Arial" pitchFamily="34" charset="-120"/>
               </a:rPr>
-              <a:t>MWh per half-hour</a:t>
+              <a:t>MWh per square</a:t>
             </a:r>
             <a:endParaRPr lang="en-US" sz="1000" dirty="0"/>
           </a:p>
@@ -45780,7 +45780,7 @@
                 <a:ea typeface="Arial" pitchFamily="34" charset="-122"/>
                 <a:cs typeface="Arial" pitchFamily="34" charset="-120"/>
               </a:rPr>
-              <a:t>GridToEv V1 model 1.1.0, +30-minute predictions for 1,434 half-hours, 2–31 January 2026 (blank: no prediction). Predictions, not recorded outcomes.</a:t>
+              <a:t>GridToEv V1 model 1.1.0, 1,434 predictions across 2–31 January 2026 (blank: no prediction). Predictions, not recorded outcomes.</a:t>
             </a:r>
             <a:endParaRPr lang="en-US" sz="1000" dirty="0"/>
           </a:p>

</xml_diff>